<commit_message>
fix: repair broken HTML slides and PPTX font substitution
- pitch.html: add display:flex/flex-direction:column to all sections so
  flex:1 children resolve correctly in reveal.js embedded mode
- pitch.html: replace height:calc(100%-Xpx) on .cols with flex:1/min-height:0
- pitch.html: remove all inline height:calc styles from slides 2, 4, 7, 8
- pitch.html: reduce stats-row margin-top 36→20px and stat .n font 3em→2.5em
  so slide 3 content fits within the 540px slide height
- pitch.html: compact card padding/icon size, shorten slide 5 card copy
  so 6-card grid fits without overflow
- generate_pitch_pptx.js: replace Syne→Trebuchet MS, DM Sans→Calibri
  to avoid PowerPoint font substitution breaking layout
- Regenerated website/pitch.pptx with corrected fonts
</commit_message>
<xml_diff>
--- a/website/pitch.pptx
+++ b/website/pitch.pptx
@@ -1705,9 +1705,9 @@
                 <a:solidFill>
                   <a:srgbClr val="E8500A"/>
                 </a:solidFill>
-                <a:latin typeface="DM Sans" pitchFamily="34" charset="0"/>
-                <a:ea typeface="DM Sans" pitchFamily="34" charset="-122"/>
-                <a:cs typeface="DM Sans" pitchFamily="34" charset="-120"/>
+                <a:latin typeface="Calibri" pitchFamily="34" charset="0"/>
+                <a:ea typeface="Calibri" pitchFamily="34" charset="-122"/>
+                <a:cs typeface="Calibri" pitchFamily="34" charset="-120"/>
               </a:rPr>
               <a:t>PARTNER PITCH · 2026</a:t>
             </a:r>
@@ -1744,9 +1744,9 @@
                 <a:solidFill>
                   <a:srgbClr val="FFFFFF"/>
                 </a:solidFill>
-                <a:latin typeface="Syne" pitchFamily="34" charset="0"/>
-                <a:ea typeface="Syne" pitchFamily="34" charset="-122"/>
-                <a:cs typeface="Syne" pitchFamily="34" charset="-120"/>
+                <a:latin typeface="Trebuchet MS" pitchFamily="34" charset="0"/>
+                <a:ea typeface="Trebuchet MS" pitchFamily="34" charset="-122"/>
+                <a:cs typeface="Trebuchet MS" pitchFamily="34" charset="-120"/>
               </a:rPr>
               <a:t>Print</a:t>
             </a:r>
@@ -1758,9 +1758,9 @@
                 <a:solidFill>
                   <a:srgbClr val="E8500A"/>
                 </a:solidFill>
-                <a:latin typeface="Syne" pitchFamily="34" charset="0"/>
-                <a:ea typeface="Syne" pitchFamily="34" charset="-122"/>
-                <a:cs typeface="Syne" pitchFamily="34" charset="-120"/>
+                <a:latin typeface="Trebuchet MS" pitchFamily="34" charset="0"/>
+                <a:ea typeface="Trebuchet MS" pitchFamily="34" charset="-122"/>
+                <a:cs typeface="Trebuchet MS" pitchFamily="34" charset="-120"/>
               </a:rPr>
               <a:t>osky</a:t>
             </a:r>
@@ -1800,9 +1800,9 @@
                 <a:solidFill>
                   <a:srgbClr val="CCCCCC"/>
                 </a:solidFill>
-                <a:latin typeface="Syne" pitchFamily="34" charset="0"/>
-                <a:ea typeface="Syne" pitchFamily="34" charset="-122"/>
-                <a:cs typeface="Syne" pitchFamily="34" charset="-120"/>
+                <a:latin typeface="Trebuchet MS" pitchFamily="34" charset="0"/>
+                <a:ea typeface="Trebuchet MS" pitchFamily="34" charset="-122"/>
+                <a:cs typeface="Trebuchet MS" pitchFamily="34" charset="-120"/>
               </a:rPr>
               <a:t>The Print Marketplace</a:t>
             </a:r>
@@ -1820,9 +1820,9 @@
                 <a:solidFill>
                   <a:srgbClr val="CCCCCC"/>
                 </a:solidFill>
-                <a:latin typeface="Syne" pitchFamily="34" charset="0"/>
-                <a:ea typeface="Syne" pitchFamily="34" charset="-122"/>
-                <a:cs typeface="Syne" pitchFamily="34" charset="-120"/>
+                <a:latin typeface="Trebuchet MS" pitchFamily="34" charset="0"/>
+                <a:ea typeface="Trebuchet MS" pitchFamily="34" charset="-122"/>
+                <a:cs typeface="Trebuchet MS" pitchFamily="34" charset="-120"/>
               </a:rPr>
               <a:t>for Thrissur.</a:t>
             </a:r>
@@ -1862,9 +1862,9 @@
                 <a:solidFill>
                   <a:srgbClr val="AAAAAA"/>
                 </a:solidFill>
-                <a:latin typeface="DM Sans" pitchFamily="34" charset="0"/>
-                <a:ea typeface="DM Sans" pitchFamily="34" charset="-122"/>
-                <a:cs typeface="DM Sans" pitchFamily="34" charset="-120"/>
+                <a:latin typeface="Calibri" pitchFamily="34" charset="0"/>
+                <a:ea typeface="Calibri" pitchFamily="34" charset="-122"/>
+                <a:cs typeface="Calibri" pitchFamily="34" charset="-120"/>
               </a:rPr>
               <a:t>WhatsApp → Quote → Pay → Print → Pickup</a:t>
             </a:r>
@@ -1882,9 +1882,9 @@
                 <a:solidFill>
                   <a:srgbClr val="AAAAAA"/>
                 </a:solidFill>
-                <a:latin typeface="DM Sans" pitchFamily="34" charset="0"/>
-                <a:ea typeface="DM Sans" pitchFamily="34" charset="-122"/>
-                <a:cs typeface="DM Sans" pitchFamily="34" charset="-120"/>
+                <a:latin typeface="Calibri" pitchFamily="34" charset="0"/>
+                <a:ea typeface="Calibri" pitchFamily="34" charset="-122"/>
+                <a:cs typeface="Calibri" pitchFamily="34" charset="-120"/>
               </a:rPr>
               <a:t>One brand. Multiple stores. Zero friction.</a:t>
             </a:r>
@@ -1982,9 +1982,9 @@
                 <a:solidFill>
                   <a:srgbClr val="E8500A"/>
                 </a:solidFill>
-                <a:latin typeface="DM Sans" pitchFamily="34" charset="0"/>
-                <a:ea typeface="DM Sans" pitchFamily="34" charset="-122"/>
-                <a:cs typeface="DM Sans" pitchFamily="34" charset="-120"/>
+                <a:latin typeface="Calibri" pitchFamily="34" charset="0"/>
+                <a:ea typeface="Calibri" pitchFamily="34" charset="-122"/>
+                <a:cs typeface="Calibri" pitchFamily="34" charset="-120"/>
               </a:rPr>
               <a:t>JOIN THE MARKETPLACE</a:t>
             </a:r>
@@ -2024,9 +2024,9 @@
                 <a:solidFill>
                   <a:srgbClr val="FFFFFF"/>
                 </a:solidFill>
-                <a:latin typeface="Syne" pitchFamily="34" charset="0"/>
-                <a:ea typeface="Syne" pitchFamily="34" charset="-122"/>
-                <a:cs typeface="Syne" pitchFamily="34" charset="-120"/>
+                <a:latin typeface="Trebuchet MS" pitchFamily="34" charset="0"/>
+                <a:ea typeface="Trebuchet MS" pitchFamily="34" charset="-122"/>
+                <a:cs typeface="Trebuchet MS" pitchFamily="34" charset="-120"/>
               </a:rPr>
               <a:t>Ready to receive pre-paid</a:t>
             </a:r>
@@ -2044,9 +2044,9 @@
                 <a:solidFill>
                   <a:srgbClr val="FFFFFF"/>
                 </a:solidFill>
-                <a:latin typeface="Syne" pitchFamily="34" charset="0"/>
-                <a:ea typeface="Syne" pitchFamily="34" charset="-122"/>
-                <a:cs typeface="Syne" pitchFamily="34" charset="-120"/>
+                <a:latin typeface="Trebuchet MS" pitchFamily="34" charset="0"/>
+                <a:ea typeface="Trebuchet MS" pitchFamily="34" charset="-122"/>
+                <a:cs typeface="Trebuchet MS" pitchFamily="34" charset="-120"/>
               </a:rPr>
               <a:t>jobs — automatically?</a:t>
             </a:r>
@@ -2086,9 +2086,9 @@
                 <a:solidFill>
                   <a:srgbClr val="AAAAAA"/>
                 </a:solidFill>
-                <a:latin typeface="DM Sans" pitchFamily="34" charset="0"/>
-                <a:ea typeface="DM Sans" pitchFamily="34" charset="-122"/>
-                <a:cs typeface="DM Sans" pitchFamily="34" charset="-120"/>
+                <a:latin typeface="Calibri" pitchFamily="34" charset="0"/>
+                <a:ea typeface="Calibri" pitchFamily="34" charset="-122"/>
+                <a:cs typeface="Calibri" pitchFamily="34" charset="-120"/>
               </a:rPr>
               <a:t>We're onboarding the first wave of partner stores in Thrissur. If your shop handles print jobs and you want a guaranteed pipeline of digital customers — let's talk.</a:t>
             </a:r>
@@ -2152,9 +2152,9 @@
                 <a:solidFill>
                   <a:srgbClr val="FFFFFF"/>
                 </a:solidFill>
-                <a:latin typeface="DM Sans" pitchFamily="34" charset="0"/>
-                <a:ea typeface="DM Sans" pitchFamily="34" charset="-122"/>
-                <a:cs typeface="DM Sans" pitchFamily="34" charset="-120"/>
+                <a:latin typeface="Calibri" pitchFamily="34" charset="0"/>
+                <a:ea typeface="Calibri" pitchFamily="34" charset="-122"/>
+                <a:cs typeface="Calibri" pitchFamily="34" charset="-120"/>
               </a:rPr>
               <a:t>Message us on WhatsApp</a:t>
             </a:r>
@@ -2218,9 +2218,9 @@
                 <a:solidFill>
                   <a:srgbClr val="CCCCCC"/>
                 </a:solidFill>
-                <a:latin typeface="DM Sans" pitchFamily="34" charset="0"/>
-                <a:ea typeface="DM Sans" pitchFamily="34" charset="-122"/>
-                <a:cs typeface="DM Sans" pitchFamily="34" charset="-120"/>
+                <a:latin typeface="Calibri" pitchFamily="34" charset="0"/>
+                <a:ea typeface="Calibri" pitchFamily="34" charset="-122"/>
+                <a:cs typeface="Calibri" pitchFamily="34" charset="-120"/>
               </a:rPr>
               <a:t>↓  Download this deck</a:t>
             </a:r>
@@ -2257,9 +2257,9 @@
                 <a:solidFill>
                   <a:srgbClr val="AAAAAA"/>
                 </a:solidFill>
-                <a:latin typeface="DM Sans" pitchFamily="34" charset="0"/>
-                <a:ea typeface="DM Sans" pitchFamily="34" charset="-122"/>
-                <a:cs typeface="DM Sans" pitchFamily="34" charset="-120"/>
+                <a:latin typeface="Calibri" pitchFamily="34" charset="0"/>
+                <a:ea typeface="Calibri" pitchFamily="34" charset="-122"/>
+                <a:cs typeface="Calibri" pitchFamily="34" charset="-120"/>
               </a:rPr>
               <a:t>wa.me/919495706405  ·  printosky.com</a:t>
             </a:r>
@@ -2355,9 +2355,9 @@
                 <a:solidFill>
                   <a:srgbClr val="E8500A"/>
                 </a:solidFill>
-                <a:latin typeface="DM Sans" pitchFamily="34" charset="0"/>
-                <a:ea typeface="DM Sans" pitchFamily="34" charset="-122"/>
-                <a:cs typeface="DM Sans" pitchFamily="34" charset="-120"/>
+                <a:latin typeface="Calibri" pitchFamily="34" charset="0"/>
+                <a:ea typeface="Calibri" pitchFamily="34" charset="-122"/>
+                <a:cs typeface="Calibri" pitchFamily="34" charset="-120"/>
               </a:rPr>
               <a:t>THE PROBLEM</a:t>
             </a:r>
@@ -2397,9 +2397,9 @@
                 <a:solidFill>
                   <a:srgbClr val="0D1117"/>
                 </a:solidFill>
-                <a:latin typeface="Syne" pitchFamily="34" charset="0"/>
-                <a:ea typeface="Syne" pitchFamily="34" charset="-122"/>
-                <a:cs typeface="Syne" pitchFamily="34" charset="-120"/>
+                <a:latin typeface="Trebuchet MS" pitchFamily="34" charset="0"/>
+                <a:ea typeface="Trebuchet MS" pitchFamily="34" charset="-122"/>
+                <a:cs typeface="Trebuchet MS" pitchFamily="34" charset="-120"/>
               </a:rPr>
               <a:t>Printing shouldn't require a treasure hunt.</a:t>
             </a:r>
@@ -2502,9 +2502,9 @@
                 <a:solidFill>
                   <a:srgbClr val="0D1117"/>
                 </a:solidFill>
-                <a:latin typeface="DM Sans" pitchFamily="34" charset="0"/>
-                <a:ea typeface="DM Sans" pitchFamily="34" charset="-122"/>
-                <a:cs typeface="DM Sans" pitchFamily="34" charset="-120"/>
+                <a:latin typeface="Calibri" pitchFamily="34" charset="0"/>
+                <a:ea typeface="Calibri" pitchFamily="34" charset="-122"/>
+                <a:cs typeface="Calibri" pitchFamily="34" charset="-120"/>
               </a:rPr>
               <a:t>Students waste 30 min hunting for a free shop — walk in, find a queue, walk out. Repeat.</a:t>
             </a:r>
@@ -2607,9 +2607,9 @@
                 <a:solidFill>
                   <a:srgbClr val="0D1117"/>
                 </a:solidFill>
-                <a:latin typeface="DM Sans" pitchFamily="34" charset="0"/>
-                <a:ea typeface="DM Sans" pitchFamily="34" charset="-122"/>
-                <a:cs typeface="DM Sans" pitchFamily="34" charset="-120"/>
+                <a:latin typeface="Calibri" pitchFamily="34" charset="0"/>
+                <a:ea typeface="Calibri" pitchFamily="34" charset="-122"/>
+                <a:cs typeface="Calibri" pitchFamily="34" charset="-120"/>
               </a:rPr>
               <a:t>No way to know if a shop is free before making the trip. Every visit is a gamble.</a:t>
             </a:r>
@@ -2712,9 +2712,9 @@
                 <a:solidFill>
                   <a:srgbClr val="0D1117"/>
                 </a:solidFill>
-                <a:latin typeface="DM Sans" pitchFamily="34" charset="0"/>
-                <a:ea typeface="DM Sans" pitchFamily="34" charset="-122"/>
-                <a:cs typeface="DM Sans" pitchFamily="34" charset="-120"/>
+                <a:latin typeface="Calibri" pitchFamily="34" charset="0"/>
+                <a:ea typeface="Calibri" pitchFamily="34" charset="-122"/>
+                <a:cs typeface="Calibri" pitchFamily="34" charset="-120"/>
               </a:rPr>
               <a:t>Stores lose jobs to each other based on proximity alone — not quality, speed, or availability.</a:t>
             </a:r>
@@ -2817,9 +2817,9 @@
                 <a:solidFill>
                   <a:srgbClr val="0D1117"/>
                 </a:solidFill>
-                <a:latin typeface="DM Sans" pitchFamily="34" charset="0"/>
-                <a:ea typeface="DM Sans" pitchFamily="34" charset="-122"/>
-                <a:cs typeface="DM Sans" pitchFamily="34" charset="-120"/>
+                <a:latin typeface="Calibri" pitchFamily="34" charset="0"/>
+                <a:ea typeface="Calibri" pitchFamily="34" charset="-122"/>
+                <a:cs typeface="Calibri" pitchFamily="34" charset="-120"/>
               </a:rPr>
               <a:t>No digital record of jobs, payments, or customers. Zero structured repeat-customer pipeline.</a:t>
             </a:r>
@@ -2883,9 +2883,9 @@
                 <a:solidFill>
                   <a:srgbClr val="FFFFFF"/>
                 </a:solidFill>
-                <a:latin typeface="Syne" pitchFamily="34" charset="0"/>
-                <a:ea typeface="Syne" pitchFamily="34" charset="-122"/>
-                <a:cs typeface="Syne" pitchFamily="34" charset="-120"/>
+                <a:latin typeface="Trebuchet MS" pitchFamily="34" charset="0"/>
+                <a:ea typeface="Trebuchet MS" pitchFamily="34" charset="-122"/>
+                <a:cs typeface="Trebuchet MS" pitchFamily="34" charset="-120"/>
               </a:rPr>
               <a:t>73%</a:t>
             </a:r>
@@ -2925,9 +2925,9 @@
                 <a:solidFill>
                   <a:srgbClr val="AAAAAA"/>
                 </a:solidFill>
-                <a:latin typeface="DM Sans" pitchFamily="34" charset="0"/>
-                <a:ea typeface="DM Sans" pitchFamily="34" charset="-122"/>
-                <a:cs typeface="DM Sans" pitchFamily="34" charset="-120"/>
+                <a:latin typeface="Calibri" pitchFamily="34" charset="0"/>
+                <a:ea typeface="Calibri" pitchFamily="34" charset="-122"/>
+                <a:cs typeface="Calibri" pitchFamily="34" charset="-120"/>
               </a:rPr>
               <a:t>of Thrissur students</a:t>
             </a:r>
@@ -2945,9 +2945,9 @@
                 <a:solidFill>
                   <a:srgbClr val="AAAAAA"/>
                 </a:solidFill>
-                <a:latin typeface="DM Sans" pitchFamily="34" charset="0"/>
-                <a:ea typeface="DM Sans" pitchFamily="34" charset="-122"/>
-                <a:cs typeface="DM Sans" pitchFamily="34" charset="-120"/>
+                <a:latin typeface="Calibri" pitchFamily="34" charset="0"/>
+                <a:ea typeface="Calibri" pitchFamily="34" charset="-122"/>
+                <a:cs typeface="Calibri" pitchFamily="34" charset="-120"/>
               </a:rPr>
               <a:t>print at least once a month</a:t>
             </a:r>
@@ -3009,9 +3009,9 @@
                 <a:solidFill>
                   <a:srgbClr val="FFFFFF"/>
                 </a:solidFill>
-                <a:latin typeface="Syne" pitchFamily="34" charset="0"/>
-                <a:ea typeface="Syne" pitchFamily="34" charset="-122"/>
-                <a:cs typeface="Syne" pitchFamily="34" charset="-120"/>
+                <a:latin typeface="Trebuchet MS" pitchFamily="34" charset="0"/>
+                <a:ea typeface="Trebuchet MS" pitchFamily="34" charset="-122"/>
+                <a:cs typeface="Trebuchet MS" pitchFamily="34" charset="-120"/>
               </a:rPr>
               <a:t>0</a:t>
             </a:r>
@@ -3051,9 +3051,9 @@
                 <a:solidFill>
                   <a:srgbClr val="AAAAAA"/>
                 </a:solidFill>
-                <a:latin typeface="DM Sans" pitchFamily="34" charset="0"/>
-                <a:ea typeface="DM Sans" pitchFamily="34" charset="-122"/>
-                <a:cs typeface="DM Sans" pitchFamily="34" charset="-120"/>
+                <a:latin typeface="Calibri" pitchFamily="34" charset="0"/>
+                <a:ea typeface="Calibri" pitchFamily="34" charset="-122"/>
+                <a:cs typeface="Calibri" pitchFamily="34" charset="-120"/>
               </a:rPr>
               <a:t>of those shops have a</a:t>
             </a:r>
@@ -3071,9 +3071,9 @@
                 <a:solidFill>
                   <a:srgbClr val="AAAAAA"/>
                 </a:solidFill>
-                <a:latin typeface="DM Sans" pitchFamily="34" charset="0"/>
-                <a:ea typeface="DM Sans" pitchFamily="34" charset="-122"/>
-                <a:cs typeface="DM Sans" pitchFamily="34" charset="-120"/>
+                <a:latin typeface="Calibri" pitchFamily="34" charset="0"/>
+                <a:ea typeface="Calibri" pitchFamily="34" charset="-122"/>
+                <a:cs typeface="Calibri" pitchFamily="34" charset="-120"/>
               </a:rPr>
               <a:t>digital ordering system</a:t>
             </a:r>
@@ -3142,9 +3142,9 @@
                 <a:solidFill>
                   <a:srgbClr val="E8500A"/>
                 </a:solidFill>
-                <a:latin typeface="DM Sans" pitchFamily="34" charset="0"/>
-                <a:ea typeface="DM Sans" pitchFamily="34" charset="-122"/>
-                <a:cs typeface="DM Sans" pitchFamily="34" charset="-120"/>
+                <a:latin typeface="Calibri" pitchFamily="34" charset="0"/>
+                <a:ea typeface="Calibri" pitchFamily="34" charset="-122"/>
+                <a:cs typeface="Calibri" pitchFamily="34" charset="-120"/>
               </a:rPr>
               <a:t>THE SOLUTION</a:t>
             </a:r>
@@ -3184,9 +3184,9 @@
                 <a:solidFill>
                   <a:srgbClr val="FFFFFF"/>
                 </a:solidFill>
-                <a:latin typeface="Syne" pitchFamily="34" charset="0"/>
-                <a:ea typeface="Syne" pitchFamily="34" charset="-122"/>
-                <a:cs typeface="Syne" pitchFamily="34" charset="-120"/>
+                <a:latin typeface="Trebuchet MS" pitchFamily="34" charset="0"/>
+                <a:ea typeface="Trebuchet MS" pitchFamily="34" charset="-122"/>
+                <a:cs typeface="Trebuchet MS" pitchFamily="34" charset="-120"/>
               </a:rPr>
               <a:t>One WhatsApp number.</a:t>
             </a:r>
@@ -3204,9 +3204,9 @@
                 <a:solidFill>
                   <a:srgbClr val="FFFFFF"/>
                 </a:solidFill>
-                <a:latin typeface="Syne" pitchFamily="34" charset="0"/>
-                <a:ea typeface="Syne" pitchFamily="34" charset="-122"/>
-                <a:cs typeface="Syne" pitchFamily="34" charset="-120"/>
+                <a:latin typeface="Trebuchet MS" pitchFamily="34" charset="0"/>
+                <a:ea typeface="Trebuchet MS" pitchFamily="34" charset="-122"/>
+                <a:cs typeface="Trebuchet MS" pitchFamily="34" charset="-120"/>
               </a:rPr>
               <a:t>Every print shop in Thrissur.</a:t>
             </a:r>
@@ -3246,9 +3246,9 @@
                 <a:solidFill>
                   <a:srgbClr val="AACCEE"/>
                 </a:solidFill>
-                <a:latin typeface="DM Sans" pitchFamily="34" charset="0"/>
-                <a:ea typeface="DM Sans" pitchFamily="34" charset="-122"/>
-                <a:cs typeface="DM Sans" pitchFamily="34" charset="-120"/>
+                <a:latin typeface="Calibri" pitchFamily="34" charset="0"/>
+                <a:ea typeface="Calibri" pitchFamily="34" charset="-122"/>
+                <a:cs typeface="Calibri" pitchFamily="34" charset="-120"/>
               </a:rPr>
               <a:t>Printosky is a unified print marketplace — customers message once, we route the job to the best available store, they pay online, and pick up with a secure code.</a:t>
             </a:r>
@@ -3285,9 +3285,9 @@
                 <a:solidFill>
                   <a:srgbClr val="FFFFFF"/>
                 </a:solidFill>
-                <a:latin typeface="Syne" pitchFamily="34" charset="0"/>
-                <a:ea typeface="Syne" pitchFamily="34" charset="-122"/>
-                <a:cs typeface="Syne" pitchFamily="34" charset="-120"/>
+                <a:latin typeface="Trebuchet MS" pitchFamily="34" charset="0"/>
+                <a:ea typeface="Trebuchet MS" pitchFamily="34" charset="-122"/>
+                <a:cs typeface="Trebuchet MS" pitchFamily="34" charset="-120"/>
               </a:rPr>
               <a:t>1</a:t>
             </a:r>
@@ -3327,9 +3327,9 @@
                 <a:solidFill>
                   <a:srgbClr val="AAAAAA"/>
                 </a:solidFill>
-                <a:latin typeface="DM Sans" pitchFamily="34" charset="0"/>
-                <a:ea typeface="DM Sans" pitchFamily="34" charset="-122"/>
-                <a:cs typeface="DM Sans" pitchFamily="34" charset="-120"/>
+                <a:latin typeface="Calibri" pitchFamily="34" charset="0"/>
+                <a:ea typeface="Calibri" pitchFamily="34" charset="-122"/>
+                <a:cs typeface="Calibri" pitchFamily="34" charset="-120"/>
               </a:rPr>
               <a:t>WhatsApp number for all stores</a:t>
             </a:r>
@@ -3366,9 +3366,9 @@
                 <a:solidFill>
                   <a:srgbClr val="FFFFFF"/>
                 </a:solidFill>
-                <a:latin typeface="Syne" pitchFamily="34" charset="0"/>
-                <a:ea typeface="Syne" pitchFamily="34" charset="-122"/>
-                <a:cs typeface="Syne" pitchFamily="34" charset="-120"/>
+                <a:latin typeface="Trebuchet MS" pitchFamily="34" charset="0"/>
+                <a:ea typeface="Trebuchet MS" pitchFamily="34" charset="-122"/>
+                <a:cs typeface="Trebuchet MS" pitchFamily="34" charset="-120"/>
               </a:rPr>
               <a:t>N</a:t>
             </a:r>
@@ -3408,9 +3408,9 @@
                 <a:solidFill>
                   <a:srgbClr val="AAAAAA"/>
                 </a:solidFill>
-                <a:latin typeface="DM Sans" pitchFamily="34" charset="0"/>
-                <a:ea typeface="DM Sans" pitchFamily="34" charset="-122"/>
-                <a:cs typeface="DM Sans" pitchFamily="34" charset="-120"/>
+                <a:latin typeface="Calibri" pitchFamily="34" charset="0"/>
+                <a:ea typeface="Calibri" pitchFamily="34" charset="-122"/>
+                <a:cs typeface="Calibri" pitchFamily="34" charset="-120"/>
               </a:rPr>
               <a:t>Partner stores sharing the job stream</a:t>
             </a:r>
@@ -3447,9 +3447,9 @@
                 <a:solidFill>
                   <a:srgbClr val="FFFFFF"/>
                 </a:solidFill>
-                <a:latin typeface="Syne" pitchFamily="34" charset="0"/>
-                <a:ea typeface="Syne" pitchFamily="34" charset="-122"/>
-                <a:cs typeface="Syne" pitchFamily="34" charset="-120"/>
+                <a:latin typeface="Trebuchet MS" pitchFamily="34" charset="0"/>
+                <a:ea typeface="Trebuchet MS" pitchFamily="34" charset="-122"/>
+                <a:cs typeface="Trebuchet MS" pitchFamily="34" charset="-120"/>
               </a:rPr>
               <a:t>0</a:t>
             </a:r>
@@ -3489,9 +3489,9 @@
                 <a:solidFill>
                   <a:srgbClr val="AAAAAA"/>
                 </a:solidFill>
-                <a:latin typeface="DM Sans" pitchFamily="34" charset="0"/>
-                <a:ea typeface="DM Sans" pitchFamily="34" charset="-122"/>
-                <a:cs typeface="DM Sans" pitchFamily="34" charset="-120"/>
+                <a:latin typeface="Calibri" pitchFamily="34" charset="0"/>
+                <a:ea typeface="Calibri" pitchFamily="34" charset="-122"/>
+                <a:cs typeface="Calibri" pitchFamily="34" charset="-120"/>
               </a:rPr>
               <a:t>Software installs required to join</a:t>
             </a:r>
@@ -3587,9 +3587,9 @@
                 <a:solidFill>
                   <a:srgbClr val="E8500A"/>
                 </a:solidFill>
-                <a:latin typeface="DM Sans" pitchFamily="34" charset="0"/>
-                <a:ea typeface="DM Sans" pitchFamily="34" charset="-122"/>
-                <a:cs typeface="DM Sans" pitchFamily="34" charset="-120"/>
+                <a:latin typeface="Calibri" pitchFamily="34" charset="0"/>
+                <a:ea typeface="Calibri" pitchFamily="34" charset="-122"/>
+                <a:cs typeface="Calibri" pitchFamily="34" charset="-120"/>
               </a:rPr>
               <a:t>CUSTOMER JOURNEY</a:t>
             </a:r>
@@ -3629,9 +3629,9 @@
                 <a:solidFill>
                   <a:srgbClr val="0D1117"/>
                 </a:solidFill>
-                <a:latin typeface="Syne" pitchFamily="34" charset="0"/>
-                <a:ea typeface="Syne" pitchFamily="34" charset="-122"/>
-                <a:cs typeface="Syne" pitchFamily="34" charset="-120"/>
+                <a:latin typeface="Trebuchet MS" pitchFamily="34" charset="0"/>
+                <a:ea typeface="Trebuchet MS" pitchFamily="34" charset="-122"/>
+                <a:cs typeface="Trebuchet MS" pitchFamily="34" charset="-120"/>
               </a:rPr>
               <a:t>How it works — in 4 steps.</a:t>
             </a:r>
@@ -3693,9 +3693,9 @@
                 <a:solidFill>
                   <a:srgbClr val="FFFFFF"/>
                 </a:solidFill>
-                <a:latin typeface="Syne" pitchFamily="34" charset="0"/>
-                <a:ea typeface="Syne" pitchFamily="34" charset="-122"/>
-                <a:cs typeface="Syne" pitchFamily="34" charset="-120"/>
+                <a:latin typeface="Trebuchet MS" pitchFamily="34" charset="0"/>
+                <a:ea typeface="Trebuchet MS" pitchFamily="34" charset="-122"/>
+                <a:cs typeface="Trebuchet MS" pitchFamily="34" charset="-120"/>
               </a:rPr>
               <a:t>1</a:t>
             </a:r>
@@ -3732,9 +3732,9 @@
                 <a:solidFill>
                   <a:srgbClr val="0D1117"/>
                 </a:solidFill>
-                <a:latin typeface="DM Sans" pitchFamily="34" charset="0"/>
-                <a:ea typeface="DM Sans" pitchFamily="34" charset="-122"/>
-                <a:cs typeface="DM Sans" pitchFamily="34" charset="-120"/>
+                <a:latin typeface="Calibri" pitchFamily="34" charset="0"/>
+                <a:ea typeface="Calibri" pitchFamily="34" charset="-122"/>
+                <a:cs typeface="Calibri" pitchFamily="34" charset="-120"/>
               </a:rPr>
               <a:t>Send file via WhatsApp</a:t>
             </a:r>
@@ -3774,9 +3774,9 @@
                 <a:solidFill>
                   <a:srgbClr val="6B7280"/>
                 </a:solidFill>
-                <a:latin typeface="DM Sans" pitchFamily="34" charset="0"/>
-                <a:ea typeface="DM Sans" pitchFamily="34" charset="-122"/>
-                <a:cs typeface="DM Sans" pitchFamily="34" charset="-120"/>
+                <a:latin typeface="Calibri" pitchFamily="34" charset="0"/>
+                <a:ea typeface="Calibri" pitchFamily="34" charset="-122"/>
+                <a:cs typeface="Calibri" pitchFamily="34" charset="-120"/>
               </a:rPr>
               <a:t>Customer messages +91 94957 06405 with their PDF. Bot responds with a quote in seconds.</a:t>
             </a:r>
@@ -3838,9 +3838,9 @@
                 <a:solidFill>
                   <a:srgbClr val="FFFFFF"/>
                 </a:solidFill>
-                <a:latin typeface="Syne" pitchFamily="34" charset="0"/>
-                <a:ea typeface="Syne" pitchFamily="34" charset="-122"/>
-                <a:cs typeface="Syne" pitchFamily="34" charset="-120"/>
+                <a:latin typeface="Trebuchet MS" pitchFamily="34" charset="0"/>
+                <a:ea typeface="Trebuchet MS" pitchFamily="34" charset="-122"/>
+                <a:cs typeface="Trebuchet MS" pitchFamily="34" charset="-120"/>
               </a:rPr>
               <a:t>2</a:t>
             </a:r>
@@ -3877,9 +3877,9 @@
                 <a:solidFill>
                   <a:srgbClr val="0D1117"/>
                 </a:solidFill>
-                <a:latin typeface="DM Sans" pitchFamily="34" charset="0"/>
-                <a:ea typeface="DM Sans" pitchFamily="34" charset="-122"/>
-                <a:cs typeface="DM Sans" pitchFamily="34" charset="-120"/>
+                <a:latin typeface="Calibri" pitchFamily="34" charset="0"/>
+                <a:ea typeface="Calibri" pitchFamily="34" charset="-122"/>
+                <a:cs typeface="Calibri" pitchFamily="34" charset="-120"/>
               </a:rPr>
               <a:t>Confirm &amp; pay online</a:t>
             </a:r>
@@ -3919,9 +3919,9 @@
                 <a:solidFill>
                   <a:srgbClr val="6B7280"/>
                 </a:solidFill>
-                <a:latin typeface="DM Sans" pitchFamily="34" charset="0"/>
-                <a:ea typeface="DM Sans" pitchFamily="34" charset="-122"/>
-                <a:cs typeface="DM Sans" pitchFamily="34" charset="-120"/>
+                <a:latin typeface="Calibri" pitchFamily="34" charset="0"/>
+                <a:ea typeface="Calibri" pitchFamily="34" charset="-122"/>
+                <a:cs typeface="Calibri" pitchFamily="34" charset="-120"/>
               </a:rPr>
               <a:t>Customer approves and pays via Razorpay (UPI, card, net banking). Full amount collected upfront.</a:t>
             </a:r>
@@ -3983,9 +3983,9 @@
                 <a:solidFill>
                   <a:srgbClr val="FFFFFF"/>
                 </a:solidFill>
-                <a:latin typeface="Syne" pitchFamily="34" charset="0"/>
-                <a:ea typeface="Syne" pitchFamily="34" charset="-122"/>
-                <a:cs typeface="Syne" pitchFamily="34" charset="-120"/>
+                <a:latin typeface="Trebuchet MS" pitchFamily="34" charset="0"/>
+                <a:ea typeface="Trebuchet MS" pitchFamily="34" charset="-122"/>
+                <a:cs typeface="Trebuchet MS" pitchFamily="34" charset="-120"/>
               </a:rPr>
               <a:t>3</a:t>
             </a:r>
@@ -4022,9 +4022,9 @@
                 <a:solidFill>
                   <a:srgbClr val="0D1117"/>
                 </a:solidFill>
-                <a:latin typeface="DM Sans" pitchFamily="34" charset="0"/>
-                <a:ea typeface="DM Sans" pitchFamily="34" charset="-122"/>
-                <a:cs typeface="DM Sans" pitchFamily="34" charset="-120"/>
+                <a:latin typeface="Calibri" pitchFamily="34" charset="0"/>
+                <a:ea typeface="Calibri" pitchFamily="34" charset="-122"/>
+                <a:cs typeface="Calibri" pitchFamily="34" charset="-120"/>
               </a:rPr>
               <a:t>Job auto-routed to best store</a:t>
             </a:r>
@@ -4064,9 +4064,9 @@
                 <a:solidFill>
                   <a:srgbClr val="6B7280"/>
                 </a:solidFill>
-                <a:latin typeface="DM Sans" pitchFamily="34" charset="0"/>
-                <a:ea typeface="DM Sans" pitchFamily="34" charset="-122"/>
-                <a:cs typeface="DM Sans" pitchFamily="34" charset="-120"/>
+                <a:latin typeface="Calibri" pitchFamily="34" charset="0"/>
+                <a:ea typeface="Calibri" pitchFamily="34" charset="-122"/>
+                <a:cs typeface="Calibri" pitchFamily="34" charset="-120"/>
               </a:rPr>
               <a:t>Routing engine scores every partner by capacity and queue depth, assigns in real time.</a:t>
             </a:r>
@@ -4128,9 +4128,9 @@
                 <a:solidFill>
                   <a:srgbClr val="FFFFFF"/>
                 </a:solidFill>
-                <a:latin typeface="Syne" pitchFamily="34" charset="0"/>
-                <a:ea typeface="Syne" pitchFamily="34" charset="-122"/>
-                <a:cs typeface="Syne" pitchFamily="34" charset="-120"/>
+                <a:latin typeface="Trebuchet MS" pitchFamily="34" charset="0"/>
+                <a:ea typeface="Trebuchet MS" pitchFamily="34" charset="-122"/>
+                <a:cs typeface="Trebuchet MS" pitchFamily="34" charset="-120"/>
               </a:rPr>
               <a:t>4</a:t>
             </a:r>
@@ -4167,9 +4167,9 @@
                 <a:solidFill>
                   <a:srgbClr val="0D1117"/>
                 </a:solidFill>
-                <a:latin typeface="DM Sans" pitchFamily="34" charset="0"/>
-                <a:ea typeface="DM Sans" pitchFamily="34" charset="-122"/>
-                <a:cs typeface="DM Sans" pitchFamily="34" charset="-120"/>
+                <a:latin typeface="Calibri" pitchFamily="34" charset="0"/>
+                <a:ea typeface="Calibri" pitchFamily="34" charset="-122"/>
+                <a:cs typeface="Calibri" pitchFamily="34" charset="-120"/>
               </a:rPr>
               <a:t>Pickup with secure code</a:t>
             </a:r>
@@ -4209,9 +4209,9 @@
                 <a:solidFill>
                   <a:srgbClr val="6B7280"/>
                 </a:solidFill>
-                <a:latin typeface="DM Sans" pitchFamily="34" charset="0"/>
-                <a:ea typeface="DM Sans" pitchFamily="34" charset="-122"/>
-                <a:cs typeface="DM Sans" pitchFamily="34" charset="-120"/>
+                <a:latin typeface="Calibri" pitchFamily="34" charset="0"/>
+                <a:ea typeface="Calibri" pitchFamily="34" charset="-122"/>
+                <a:cs typeface="Calibri" pitchFamily="34" charset="-120"/>
               </a:rPr>
               <a:t>Customer gets a unique P-XXXX code via WhatsApp. Show it at the counter, collect the job.</a:t>
             </a:r>
@@ -4302,9 +4302,9 @@
                 <a:solidFill>
                   <a:srgbClr val="25D366"/>
                 </a:solidFill>
-                <a:latin typeface="DM Sans" pitchFamily="34" charset="0"/>
-                <a:ea typeface="DM Sans" pitchFamily="34" charset="-122"/>
-                <a:cs typeface="DM Sans" pitchFamily="34" charset="-120"/>
+                <a:latin typeface="Calibri" pitchFamily="34" charset="0"/>
+                <a:ea typeface="Calibri" pitchFamily="34" charset="-122"/>
+                <a:cs typeface="Calibri" pitchFamily="34" charset="-120"/>
               </a:rPr>
               <a:t>💬 Customer</a:t>
             </a:r>
@@ -4344,9 +4344,9 @@
                 <a:solidFill>
                   <a:srgbClr val="0D1117"/>
                 </a:solidFill>
-                <a:latin typeface="DM Sans" pitchFamily="34" charset="0"/>
-                <a:ea typeface="DM Sans" pitchFamily="34" charset="-122"/>
-                <a:cs typeface="DM Sans" pitchFamily="34" charset="-120"/>
+                <a:latin typeface="Calibri" pitchFamily="34" charset="0"/>
+                <a:ea typeface="Calibri" pitchFamily="34" charset="-122"/>
+                <a:cs typeface="Calibri" pitchFamily="34" charset="-120"/>
               </a:rPr>
               <a:t>"Hi, 40 pages B&amp;W A4, single side."</a:t>
             </a:r>
@@ -4410,9 +4410,9 @@
                 <a:solidFill>
                   <a:srgbClr val="FFFFFF"/>
                 </a:solidFill>
-                <a:latin typeface="DM Sans" pitchFamily="34" charset="0"/>
-                <a:ea typeface="DM Sans" pitchFamily="34" charset="-122"/>
-                <a:cs typeface="DM Sans" pitchFamily="34" charset="-120"/>
+                <a:latin typeface="Calibri" pitchFamily="34" charset="0"/>
+                <a:ea typeface="Calibri" pitchFamily="34" charset="-122"/>
+                <a:cs typeface="Calibri" pitchFamily="34" charset="-120"/>
               </a:rPr>
               <a:t>🤖 Printosky</a:t>
             </a:r>
@@ -4452,9 +4452,9 @@
                 <a:solidFill>
                   <a:srgbClr val="FFFFFF"/>
                 </a:solidFill>
-                <a:latin typeface="DM Sans" pitchFamily="34" charset="0"/>
-                <a:ea typeface="DM Sans" pitchFamily="34" charset="-122"/>
-                <a:cs typeface="DM Sans" pitchFamily="34" charset="-120"/>
+                <a:latin typeface="Calibri" pitchFamily="34" charset="0"/>
+                <a:ea typeface="Calibri" pitchFamily="34" charset="-122"/>
+                <a:cs typeface="Calibri" pitchFamily="34" charset="-120"/>
               </a:rPr>
               <a:t>40 pages B&amp;W A4 = ₹20. Pay here →</a:t>
             </a:r>
@@ -4518,9 +4518,9 @@
                 <a:solidFill>
                   <a:srgbClr val="6B7280"/>
                 </a:solidFill>
-                <a:latin typeface="DM Sans" pitchFamily="34" charset="0"/>
-                <a:ea typeface="DM Sans" pitchFamily="34" charset="-122"/>
-                <a:cs typeface="DM Sans" pitchFamily="34" charset="-120"/>
+                <a:latin typeface="Calibri" pitchFamily="34" charset="0"/>
+                <a:ea typeface="Calibri" pitchFamily="34" charset="-122"/>
+                <a:cs typeface="Calibri" pitchFamily="34" charset="-120"/>
               </a:rPr>
               <a:t>✅ Confirmed</a:t>
             </a:r>
@@ -4560,9 +4560,9 @@
                 <a:solidFill>
                   <a:srgbClr val="0D1117"/>
                 </a:solidFill>
-                <a:latin typeface="DM Sans" pitchFamily="34" charset="0"/>
-                <a:ea typeface="DM Sans" pitchFamily="34" charset="-122"/>
-                <a:cs typeface="DM Sans" pitchFamily="34" charset="-120"/>
+                <a:latin typeface="Calibri" pitchFamily="34" charset="0"/>
+                <a:ea typeface="Calibri" pitchFamily="34" charset="-122"/>
+                <a:cs typeface="Calibri" pitchFamily="34" charset="-120"/>
               </a:rPr>
               <a:t>"Order confirmed. Routed to OSP Thriprayar."</a:t>
             </a:r>
@@ -4626,9 +4626,9 @@
                 <a:solidFill>
                   <a:srgbClr val="FFFFFF"/>
                 </a:solidFill>
-                <a:latin typeface="DM Sans" pitchFamily="34" charset="0"/>
-                <a:ea typeface="DM Sans" pitchFamily="34" charset="-122"/>
-                <a:cs typeface="DM Sans" pitchFamily="34" charset="-120"/>
+                <a:latin typeface="Calibri" pitchFamily="34" charset="0"/>
+                <a:ea typeface="Calibri" pitchFamily="34" charset="-122"/>
+                <a:cs typeface="Calibri" pitchFamily="34" charset="-120"/>
               </a:rPr>
               <a:t>🔔 Ready</a:t>
             </a:r>
@@ -4668,9 +4668,9 @@
                 <a:solidFill>
                   <a:srgbClr val="FFFFFF"/>
                 </a:solidFill>
-                <a:latin typeface="DM Sans" pitchFamily="34" charset="0"/>
-                <a:ea typeface="DM Sans" pitchFamily="34" charset="-122"/>
-                <a:cs typeface="DM Sans" pitchFamily="34" charset="-120"/>
+                <a:latin typeface="Calibri" pitchFamily="34" charset="0"/>
+                <a:ea typeface="Calibri" pitchFamily="34" charset="-122"/>
+                <a:cs typeface="Calibri" pitchFamily="34" charset="-120"/>
               </a:rPr>
               <a:t>Pickup code: P-4K8X</a:t>
             </a:r>
@@ -4688,9 +4688,9 @@
                 <a:solidFill>
                   <a:srgbClr val="FFFFFF"/>
                 </a:solidFill>
-                <a:latin typeface="DM Sans" pitchFamily="34" charset="0"/>
-                <a:ea typeface="DM Sans" pitchFamily="34" charset="-122"/>
-                <a:cs typeface="DM Sans" pitchFamily="34" charset="-120"/>
+                <a:latin typeface="Calibri" pitchFamily="34" charset="0"/>
+                <a:ea typeface="Calibri" pitchFamily="34" charset="-122"/>
+                <a:cs typeface="Calibri" pitchFamily="34" charset="-120"/>
               </a:rPr>
               <a:t>Address: OSP, Thriprayar</a:t>
             </a:r>
@@ -4759,9 +4759,9 @@
                 <a:solidFill>
                   <a:srgbClr val="E8500A"/>
                 </a:solidFill>
-                <a:latin typeface="DM Sans" pitchFamily="34" charset="0"/>
-                <a:ea typeface="DM Sans" pitchFamily="34" charset="-122"/>
-                <a:cs typeface="DM Sans" pitchFamily="34" charset="-120"/>
+                <a:latin typeface="Calibri" pitchFamily="34" charset="0"/>
+                <a:ea typeface="Calibri" pitchFamily="34" charset="-122"/>
+                <a:cs typeface="Calibri" pitchFamily="34" charset="-120"/>
               </a:rPr>
               <a:t>FOR PARTNER STORES</a:t>
             </a:r>
@@ -4801,9 +4801,9 @@
                 <a:solidFill>
                   <a:srgbClr val="0D1117"/>
                 </a:solidFill>
-                <a:latin typeface="Syne" pitchFamily="34" charset="0"/>
-                <a:ea typeface="Syne" pitchFamily="34" charset="-122"/>
-                <a:cs typeface="Syne" pitchFamily="34" charset="-120"/>
+                <a:latin typeface="Trebuchet MS" pitchFamily="34" charset="0"/>
+                <a:ea typeface="Trebuchet MS" pitchFamily="34" charset="-122"/>
+                <a:cs typeface="Trebuchet MS" pitchFamily="34" charset="-120"/>
               </a:rPr>
               <a:t>Join Printosky. Get jobs. No software needed.</a:t>
             </a:r>
@@ -4843,9 +4843,9 @@
                 <a:solidFill>
                   <a:srgbClr val="6B7280"/>
                 </a:solidFill>
-                <a:latin typeface="DM Sans" pitchFamily="34" charset="0"/>
-                <a:ea typeface="DM Sans" pitchFamily="34" charset="-122"/>
-                <a:cs typeface="DM Sans" pitchFamily="34" charset="-120"/>
+                <a:latin typeface="Calibri" pitchFamily="34" charset="0"/>
+                <a:ea typeface="Calibri" pitchFamily="34" charset="-122"/>
+                <a:cs typeface="Calibri" pitchFamily="34" charset="-120"/>
               </a:rPr>
               <a:t>Partner stores receive jobs via WhatsApp — no API, no software install. Tap ACCEPT, print, mark ready.</a:t>
             </a:r>
@@ -4945,9 +4945,9 @@
                 <a:solidFill>
                   <a:srgbClr val="0D1117"/>
                 </a:solidFill>
-                <a:latin typeface="Syne" pitchFamily="34" charset="0"/>
-                <a:ea typeface="Syne" pitchFamily="34" charset="-122"/>
-                <a:cs typeface="Syne" pitchFamily="34" charset="-120"/>
+                <a:latin typeface="Trebuchet MS" pitchFamily="34" charset="0"/>
+                <a:ea typeface="Trebuchet MS" pitchFamily="34" charset="-122"/>
+                <a:cs typeface="Trebuchet MS" pitchFamily="34" charset="-120"/>
               </a:rPr>
               <a:t>WhatsApp dispatch</a:t>
             </a:r>
@@ -4987,9 +4987,9 @@
                 <a:solidFill>
                   <a:srgbClr val="6B7280"/>
                 </a:solidFill>
-                <a:latin typeface="DM Sans" pitchFamily="34" charset="0"/>
-                <a:ea typeface="DM Sans" pitchFamily="34" charset="-122"/>
-                <a:cs typeface="DM Sans" pitchFamily="34" charset="-120"/>
+                <a:latin typeface="Calibri" pitchFamily="34" charset="0"/>
+                <a:ea typeface="Calibri" pitchFamily="34" charset="-122"/>
+                <a:cs typeface="Calibri" pitchFamily="34" charset="-120"/>
               </a:rPr>
               <a:t>Jobs arrive as WhatsApp messages with the file, specs, and pickup code. Tap ACCEPT to claim.</a:t>
             </a:r>
@@ -5089,9 +5089,9 @@
                 <a:solidFill>
                   <a:srgbClr val="0D1117"/>
                 </a:solidFill>
-                <a:latin typeface="Syne" pitchFamily="34" charset="0"/>
-                <a:ea typeface="Syne" pitchFamily="34" charset="-122"/>
-                <a:cs typeface="Syne" pitchFamily="34" charset="-120"/>
+                <a:latin typeface="Trebuchet MS" pitchFamily="34" charset="0"/>
+                <a:ea typeface="Trebuchet MS" pitchFamily="34" charset="-122"/>
+                <a:cs typeface="Trebuchet MS" pitchFamily="34" charset="-120"/>
               </a:rPr>
               <a:t>Automatic routing</a:t>
             </a:r>
@@ -5131,9 +5131,9 @@
                 <a:solidFill>
                   <a:srgbClr val="6B7280"/>
                 </a:solidFill>
-                <a:latin typeface="DM Sans" pitchFamily="34" charset="0"/>
-                <a:ea typeface="DM Sans" pitchFamily="34" charset="-122"/>
-                <a:cs typeface="DM Sans" pitchFamily="34" charset="-120"/>
+                <a:latin typeface="Calibri" pitchFamily="34" charset="0"/>
+                <a:ea typeface="Calibri" pitchFamily="34" charset="-122"/>
+                <a:cs typeface="Calibri" pitchFamily="34" charset="-120"/>
               </a:rPr>
               <a:t>Engine sends jobs to the best available store. No bidding. No chasing customers.</a:t>
             </a:r>
@@ -5233,9 +5233,9 @@
                 <a:solidFill>
                   <a:srgbClr val="0D1117"/>
                 </a:solidFill>
-                <a:latin typeface="Syne" pitchFamily="34" charset="0"/>
-                <a:ea typeface="Syne" pitchFamily="34" charset="-122"/>
-                <a:cs typeface="Syne" pitchFamily="34" charset="-120"/>
+                <a:latin typeface="Trebuchet MS" pitchFamily="34" charset="0"/>
+                <a:ea typeface="Trebuchet MS" pitchFamily="34" charset="-122"/>
+                <a:cs typeface="Trebuchet MS" pitchFamily="34" charset="-120"/>
               </a:rPr>
               <a:t>Instant Razorpay payouts</a:t>
             </a:r>
@@ -5275,9 +5275,9 @@
                 <a:solidFill>
                   <a:srgbClr val="6B7280"/>
                 </a:solidFill>
-                <a:latin typeface="DM Sans" pitchFamily="34" charset="0"/>
-                <a:ea typeface="DM Sans" pitchFamily="34" charset="-122"/>
-                <a:cs typeface="DM Sans" pitchFamily="34" charset="-120"/>
+                <a:latin typeface="Calibri" pitchFamily="34" charset="0"/>
+                <a:ea typeface="Calibri" pitchFamily="34" charset="-122"/>
+                <a:cs typeface="Calibri" pitchFamily="34" charset="-120"/>
               </a:rPr>
               <a:t>Payment splits on completion. Your share lands in your account — zero manual settlement.</a:t>
             </a:r>
@@ -5377,9 +5377,9 @@
                 <a:solidFill>
                   <a:srgbClr val="0D1117"/>
                 </a:solidFill>
-                <a:latin typeface="Syne" pitchFamily="34" charset="0"/>
-                <a:ea typeface="Syne" pitchFamily="34" charset="-122"/>
-                <a:cs typeface="Syne" pitchFamily="34" charset="-120"/>
+                <a:latin typeface="Trebuchet MS" pitchFamily="34" charset="0"/>
+                <a:ea typeface="Trebuchet MS" pitchFamily="34" charset="-122"/>
+                <a:cs typeface="Trebuchet MS" pitchFamily="34" charset="-120"/>
               </a:rPr>
               <a:t>Pickup code verification</a:t>
             </a:r>
@@ -5419,9 +5419,9 @@
                 <a:solidFill>
                   <a:srgbClr val="6B7280"/>
                 </a:solidFill>
-                <a:latin typeface="DM Sans" pitchFamily="34" charset="0"/>
-                <a:ea typeface="DM Sans" pitchFamily="34" charset="-122"/>
-                <a:cs typeface="DM Sans" pitchFamily="34" charset="-120"/>
+                <a:latin typeface="Calibri" pitchFamily="34" charset="0"/>
+                <a:ea typeface="Calibri" pitchFamily="34" charset="-122"/>
+                <a:cs typeface="Calibri" pitchFamily="34" charset="-120"/>
               </a:rPr>
               <a:t>Customers show a P-XXXX code at counter. No name lookup, no receipt confusion.</a:t>
             </a:r>
@@ -5521,9 +5521,9 @@
                 <a:solidFill>
                   <a:srgbClr val="0D1117"/>
                 </a:solidFill>
-                <a:latin typeface="Syne" pitchFamily="34" charset="0"/>
-                <a:ea typeface="Syne" pitchFamily="34" charset="-122"/>
-                <a:cs typeface="Syne" pitchFamily="34" charset="-120"/>
+                <a:latin typeface="Trebuchet MS" pitchFamily="34" charset="0"/>
+                <a:ea typeface="Trebuchet MS" pitchFamily="34" charset="-122"/>
+                <a:cs typeface="Trebuchet MS" pitchFamily="34" charset="-120"/>
               </a:rPr>
               <a:t>Live order tracking</a:t>
             </a:r>
@@ -5563,9 +5563,9 @@
                 <a:solidFill>
                   <a:srgbClr val="6B7280"/>
                 </a:solidFill>
-                <a:latin typeface="DM Sans" pitchFamily="34" charset="0"/>
-                <a:ea typeface="DM Sans" pitchFamily="34" charset="-122"/>
-                <a:cs typeface="DM Sans" pitchFamily="34" charset="-120"/>
+                <a:latin typeface="Calibri" pitchFamily="34" charset="0"/>
+                <a:ea typeface="Calibri" pitchFamily="34" charset="-122"/>
+                <a:cs typeface="Calibri" pitchFamily="34" charset="-120"/>
               </a:rPr>
               <a:t>Customers track at printosky.com/track — no calls asking "is it done yet?"</a:t>
             </a:r>
@@ -5665,9 +5665,9 @@
                 <a:solidFill>
                   <a:srgbClr val="0D1117"/>
                 </a:solidFill>
-                <a:latin typeface="Syne" pitchFamily="34" charset="0"/>
-                <a:ea typeface="Syne" pitchFamily="34" charset="-122"/>
-                <a:cs typeface="Syne" pitchFamily="34" charset="-120"/>
+                <a:latin typeface="Trebuchet MS" pitchFamily="34" charset="0"/>
+                <a:ea typeface="Trebuchet MS" pitchFamily="34" charset="-122"/>
+                <a:cs typeface="Trebuchet MS" pitchFamily="34" charset="-120"/>
               </a:rPr>
               <a:t>Keep your setup</a:t>
             </a:r>
@@ -5707,9 +5707,9 @@
                 <a:solidFill>
                   <a:srgbClr val="6B7280"/>
                 </a:solidFill>
-                <a:latin typeface="DM Sans" pitchFamily="34" charset="0"/>
-                <a:ea typeface="DM Sans" pitchFamily="34" charset="-122"/>
-                <a:cs typeface="DM Sans" pitchFamily="34" charset="-120"/>
+                <a:latin typeface="Calibri" pitchFamily="34" charset="0"/>
+                <a:ea typeface="Calibri" pitchFamily="34" charset="-122"/>
+                <a:cs typeface="Calibri" pitchFamily="34" charset="-120"/>
               </a:rPr>
               <a:t>Your printers, your folder system — we wrap around what you have. Nothing changes.</a:t>
             </a:r>
@@ -5778,9 +5778,9 @@
                 <a:solidFill>
                   <a:srgbClr val="E8500A"/>
                 </a:solidFill>
-                <a:latin typeface="DM Sans" pitchFamily="34" charset="0"/>
-                <a:ea typeface="DM Sans" pitchFamily="34" charset="-122"/>
-                <a:cs typeface="DM Sans" pitchFamily="34" charset="-120"/>
+                <a:latin typeface="Calibri" pitchFamily="34" charset="0"/>
+                <a:ea typeface="Calibri" pitchFamily="34" charset="-122"/>
+                <a:cs typeface="Calibri" pitchFamily="34" charset="-120"/>
               </a:rPr>
               <a:t>THE TECHNOLOGY</a:t>
             </a:r>
@@ -5820,9 +5820,9 @@
                 <a:solidFill>
                   <a:srgbClr val="FFFFFF"/>
                 </a:solidFill>
-                <a:latin typeface="Syne" pitchFamily="34" charset="0"/>
-                <a:ea typeface="Syne" pitchFamily="34" charset="-122"/>
-                <a:cs typeface="Syne" pitchFamily="34" charset="-120"/>
+                <a:latin typeface="Trebuchet MS" pitchFamily="34" charset="0"/>
+                <a:ea typeface="Trebuchet MS" pitchFamily="34" charset="-122"/>
+                <a:cs typeface="Trebuchet MS" pitchFamily="34" charset="-120"/>
               </a:rPr>
               <a:t>Smart routing. Every job to the right store.</a:t>
             </a:r>
@@ -5862,9 +5862,9 @@
                 <a:solidFill>
                   <a:srgbClr val="AAAAAA"/>
                 </a:solidFill>
-                <a:latin typeface="DM Sans" pitchFamily="34" charset="0"/>
-                <a:ea typeface="DM Sans" pitchFamily="34" charset="-122"/>
-                <a:cs typeface="DM Sans" pitchFamily="34" charset="-120"/>
+                <a:latin typeface="Calibri" pitchFamily="34" charset="0"/>
+                <a:ea typeface="Calibri" pitchFamily="34" charset="-122"/>
+                <a:cs typeface="Calibri" pitchFamily="34" charset="-120"/>
               </a:rPr>
               <a:t>When a customer pays, our routing engine scores every partner store in real time — by capacity, queue depth, and paper availability — then assigns automatically.</a:t>
             </a:r>
@@ -5928,9 +5928,9 @@
                 <a:solidFill>
                   <a:srgbClr val="AAAAAA"/>
                 </a:solidFill>
-                <a:latin typeface="DM Sans" pitchFamily="34" charset="0"/>
-                <a:ea typeface="DM Sans" pitchFamily="34" charset="-122"/>
-                <a:cs typeface="DM Sans" pitchFamily="34" charset="-120"/>
+                <a:latin typeface="Calibri" pitchFamily="34" charset="0"/>
+                <a:ea typeface="Calibri" pitchFamily="34" charset="-122"/>
+                <a:cs typeface="Calibri" pitchFamily="34" charset="-120"/>
               </a:rPr>
               <a:t>INCOMING JOB</a:t>
             </a:r>
@@ -5967,9 +5967,9 @@
                 <a:solidFill>
                   <a:srgbClr val="FFFFFF"/>
                 </a:solidFill>
-                <a:latin typeface="Syne" pitchFamily="34" charset="0"/>
-                <a:ea typeface="Syne" pitchFamily="34" charset="-122"/>
-                <a:cs typeface="Syne" pitchFamily="34" charset="-120"/>
+                <a:latin typeface="Trebuchet MS" pitchFamily="34" charset="0"/>
+                <a:ea typeface="Trebuchet MS" pitchFamily="34" charset="-122"/>
+                <a:cs typeface="Trebuchet MS" pitchFamily="34" charset="-120"/>
               </a:rPr>
               <a:t>40pg B&amp;W A4</a:t>
             </a:r>
@@ -6033,9 +6033,9 @@
                 <a:solidFill>
                   <a:srgbClr val="FFDDCC"/>
                 </a:solidFill>
-                <a:latin typeface="DM Sans" pitchFamily="34" charset="0"/>
-                <a:ea typeface="DM Sans" pitchFamily="34" charset="-122"/>
-                <a:cs typeface="DM Sans" pitchFamily="34" charset="-120"/>
+                <a:latin typeface="Calibri" pitchFamily="34" charset="0"/>
+                <a:ea typeface="Calibri" pitchFamily="34" charset="-122"/>
+                <a:cs typeface="Calibri" pitchFamily="34" charset="-120"/>
               </a:rPr>
               <a:t>ROUTING ENGINE</a:t>
             </a:r>
@@ -6072,9 +6072,9 @@
                 <a:solidFill>
                   <a:srgbClr val="FFFFFF"/>
                 </a:solidFill>
-                <a:latin typeface="Syne" pitchFamily="34" charset="0"/>
-                <a:ea typeface="Syne" pitchFamily="34" charset="-122"/>
-                <a:cs typeface="Syne" pitchFamily="34" charset="-120"/>
+                <a:latin typeface="Trebuchet MS" pitchFamily="34" charset="0"/>
+                <a:ea typeface="Trebuchet MS" pitchFamily="34" charset="-122"/>
+                <a:cs typeface="Trebuchet MS" pitchFamily="34" charset="-120"/>
               </a:rPr>
               <a:t>⚡ Scoring...</a:t>
             </a:r>
@@ -6138,9 +6138,9 @@
                 <a:solidFill>
                   <a:srgbClr val="AAAAAA"/>
                 </a:solidFill>
-                <a:latin typeface="DM Sans" pitchFamily="34" charset="0"/>
-                <a:ea typeface="DM Sans" pitchFamily="34" charset="-122"/>
-                <a:cs typeface="DM Sans" pitchFamily="34" charset="-120"/>
+                <a:latin typeface="Calibri" pitchFamily="34" charset="0"/>
+                <a:ea typeface="Calibri" pitchFamily="34" charset="-122"/>
+                <a:cs typeface="Calibri" pitchFamily="34" charset="-120"/>
               </a:rPr>
               <a:t>BEST STORE</a:t>
             </a:r>
@@ -6177,9 +6177,9 @@
                 <a:solidFill>
                   <a:srgbClr val="FFFFFF"/>
                 </a:solidFill>
-                <a:latin typeface="Syne" pitchFamily="34" charset="0"/>
-                <a:ea typeface="Syne" pitchFamily="34" charset="-122"/>
-                <a:cs typeface="Syne" pitchFamily="34" charset="-120"/>
+                <a:latin typeface="Trebuchet MS" pitchFamily="34" charset="0"/>
+                <a:ea typeface="Trebuchet MS" pitchFamily="34" charset="-122"/>
+                <a:cs typeface="Trebuchet MS" pitchFamily="34" charset="-120"/>
               </a:rPr>
               <a:t>OSP Thriprayar</a:t>
             </a:r>
@@ -6315,9 +6315,9 @@
                 <a:solidFill>
                   <a:srgbClr val="FFFFFF"/>
                 </a:solidFill>
-                <a:latin typeface="Syne" pitchFamily="34" charset="0"/>
-                <a:ea typeface="Syne" pitchFamily="34" charset="-122"/>
-                <a:cs typeface="Syne" pitchFamily="34" charset="-120"/>
+                <a:latin typeface="Trebuchet MS" pitchFamily="34" charset="0"/>
+                <a:ea typeface="Trebuchet MS" pitchFamily="34" charset="-122"/>
+                <a:cs typeface="Trebuchet MS" pitchFamily="34" charset="-120"/>
               </a:rPr>
               <a:t>60 s ack timeout</a:t>
             </a:r>
@@ -6357,9 +6357,9 @@
                 <a:solidFill>
                   <a:srgbClr val="AAAAAA"/>
                 </a:solidFill>
-                <a:latin typeface="DM Sans" pitchFamily="34" charset="0"/>
-                <a:ea typeface="DM Sans" pitchFamily="34" charset="-122"/>
-                <a:cs typeface="DM Sans" pitchFamily="34" charset="-120"/>
+                <a:latin typeface="Calibri" pitchFamily="34" charset="0"/>
+                <a:ea typeface="Calibri" pitchFamily="34" charset="-122"/>
+                <a:cs typeface="Calibri" pitchFamily="34" charset="-120"/>
               </a:rPr>
               <a:t>No response in 60 s? Job auto-routes to the next best store. No job left behind.</a:t>
             </a:r>
@@ -6423,9 +6423,9 @@
                 <a:solidFill>
                   <a:srgbClr val="FFFFFF"/>
                 </a:solidFill>
-                <a:latin typeface="Syne" pitchFamily="34" charset="0"/>
-                <a:ea typeface="Syne" pitchFamily="34" charset="-122"/>
-                <a:cs typeface="Syne" pitchFamily="34" charset="-120"/>
+                <a:latin typeface="Trebuchet MS" pitchFamily="34" charset="0"/>
+                <a:ea typeface="Trebuchet MS" pitchFamily="34" charset="-122"/>
+                <a:cs typeface="Trebuchet MS" pitchFamily="34" charset="-120"/>
               </a:rPr>
               <a:t>Capacity-aware</a:t>
             </a:r>
@@ -6465,9 +6465,9 @@
                 <a:solidFill>
                   <a:srgbClr val="AAAAAA"/>
                 </a:solidFill>
-                <a:latin typeface="DM Sans" pitchFamily="34" charset="0"/>
-                <a:ea typeface="DM Sans" pitchFamily="34" charset="-122"/>
-                <a:cs typeface="DM Sans" pitchFamily="34" charset="-120"/>
+                <a:latin typeface="Calibri" pitchFamily="34" charset="0"/>
+                <a:ea typeface="Calibri" pitchFamily="34" charset="-122"/>
+                <a:cs typeface="Calibri" pitchFamily="34" charset="-120"/>
               </a:rPr>
               <a:t>Stores declare daily capacity and paper types. Engine never overloads a store.</a:t>
             </a:r>
@@ -6531,9 +6531,9 @@
                 <a:solidFill>
                   <a:srgbClr val="FFFFFF"/>
                 </a:solidFill>
-                <a:latin typeface="Syne" pitchFamily="34" charset="0"/>
-                <a:ea typeface="Syne" pitchFamily="34" charset="-122"/>
-                <a:cs typeface="Syne" pitchFamily="34" charset="-120"/>
+                <a:latin typeface="Trebuchet MS" pitchFamily="34" charset="0"/>
+                <a:ea typeface="Trebuchet MS" pitchFamily="34" charset="-122"/>
+                <a:cs typeface="Trebuchet MS" pitchFamily="34" charset="-120"/>
               </a:rPr>
               <a:t>Full audit trail</a:t>
             </a:r>
@@ -6573,9 +6573,9 @@
                 <a:solidFill>
                   <a:srgbClr val="AAAAAA"/>
                 </a:solidFill>
-                <a:latin typeface="DM Sans" pitchFamily="34" charset="0"/>
-                <a:ea typeface="DM Sans" pitchFamily="34" charset="-122"/>
-                <a:cs typeface="DM Sans" pitchFamily="34" charset="-120"/>
+                <a:latin typeface="Calibri" pitchFamily="34" charset="0"/>
+                <a:ea typeface="Calibri" pitchFamily="34" charset="-122"/>
+                <a:cs typeface="Calibri" pitchFamily="34" charset="-120"/>
               </a:rPr>
               <a:t>Every routing decision is logged. Fairness disputes resolved with data, not arguments.</a:t>
             </a:r>
@@ -6644,9 +6644,9 @@
                 <a:solidFill>
                   <a:srgbClr val="E8500A"/>
                 </a:solidFill>
-                <a:latin typeface="DM Sans" pitchFamily="34" charset="0"/>
-                <a:ea typeface="DM Sans" pitchFamily="34" charset="-122"/>
-                <a:cs typeface="DM Sans" pitchFamily="34" charset="-120"/>
+                <a:latin typeface="Calibri" pitchFamily="34" charset="0"/>
+                <a:ea typeface="Calibri" pitchFamily="34" charset="-122"/>
+                <a:cs typeface="Calibri" pitchFamily="34" charset="-120"/>
               </a:rPr>
               <a:t>PAYMENTS</a:t>
             </a:r>
@@ -6686,9 +6686,9 @@
                 <a:solidFill>
                   <a:srgbClr val="0D1117"/>
                 </a:solidFill>
-                <a:latin typeface="Syne" pitchFamily="34" charset="0"/>
-                <a:ea typeface="Syne" pitchFamily="34" charset="-122"/>
-                <a:cs typeface="Syne" pitchFamily="34" charset="-120"/>
+                <a:latin typeface="Trebuchet MS" pitchFamily="34" charset="0"/>
+                <a:ea typeface="Trebuchet MS" pitchFamily="34" charset="-122"/>
+                <a:cs typeface="Trebuchet MS" pitchFamily="34" charset="-120"/>
               </a:rPr>
               <a:t>Razorpay Route splits every payment instantly.</a:t>
             </a:r>
@@ -6750,9 +6750,9 @@
                 <a:solidFill>
                   <a:srgbClr val="FFFFFF"/>
                 </a:solidFill>
-                <a:latin typeface="Syne" pitchFamily="34" charset="0"/>
-                <a:ea typeface="Syne" pitchFamily="34" charset="-122"/>
-                <a:cs typeface="Syne" pitchFamily="34" charset="-120"/>
+                <a:latin typeface="Trebuchet MS" pitchFamily="34" charset="0"/>
+                <a:ea typeface="Trebuchet MS" pitchFamily="34" charset="-122"/>
+                <a:cs typeface="Trebuchet MS" pitchFamily="34" charset="-120"/>
               </a:rPr>
               <a:t>₹</a:t>
             </a:r>
@@ -6789,9 +6789,9 @@
                 <a:solidFill>
                   <a:srgbClr val="0D1117"/>
                 </a:solidFill>
-                <a:latin typeface="DM Sans" pitchFamily="34" charset="0"/>
-                <a:ea typeface="DM Sans" pitchFamily="34" charset="-122"/>
-                <a:cs typeface="DM Sans" pitchFamily="34" charset="-120"/>
+                <a:latin typeface="Calibri" pitchFamily="34" charset="0"/>
+                <a:ea typeface="Calibri" pitchFamily="34" charset="-122"/>
+                <a:cs typeface="Calibri" pitchFamily="34" charset="-120"/>
               </a:rPr>
               <a:t>Customer pays full amount upfront</a:t>
             </a:r>
@@ -6831,9 +6831,9 @@
                 <a:solidFill>
                   <a:srgbClr val="6B7280"/>
                 </a:solidFill>
-                <a:latin typeface="DM Sans" pitchFamily="34" charset="0"/>
-                <a:ea typeface="DM Sans" pitchFamily="34" charset="-122"/>
-                <a:cs typeface="DM Sans" pitchFamily="34" charset="-120"/>
+                <a:latin typeface="Calibri" pitchFamily="34" charset="0"/>
+                <a:ea typeface="Calibri" pitchFamily="34" charset="-122"/>
+                <a:cs typeface="Calibri" pitchFamily="34" charset="-120"/>
               </a:rPr>
               <a:t>Collected at order time via UPI, card, or net banking.</a:t>
             </a:r>
@@ -6895,9 +6895,9 @@
                 <a:solidFill>
                   <a:srgbClr val="FFFFFF"/>
                 </a:solidFill>
-                <a:latin typeface="Syne" pitchFamily="34" charset="0"/>
-                <a:ea typeface="Syne" pitchFamily="34" charset="-122"/>
-                <a:cs typeface="Syne" pitchFamily="34" charset="-120"/>
+                <a:latin typeface="Trebuchet MS" pitchFamily="34" charset="0"/>
+                <a:ea typeface="Trebuchet MS" pitchFamily="34" charset="-122"/>
+                <a:cs typeface="Trebuchet MS" pitchFamily="34" charset="-120"/>
               </a:rPr>
               <a:t>⚡</a:t>
             </a:r>
@@ -6934,9 +6934,9 @@
                 <a:solidFill>
                   <a:srgbClr val="0D1117"/>
                 </a:solidFill>
-                <a:latin typeface="DM Sans" pitchFamily="34" charset="0"/>
-                <a:ea typeface="DM Sans" pitchFamily="34" charset="-122"/>
-                <a:cs typeface="DM Sans" pitchFamily="34" charset="-120"/>
+                <a:latin typeface="Calibri" pitchFamily="34" charset="0"/>
+                <a:ea typeface="Calibri" pitchFamily="34" charset="-122"/>
+                <a:cs typeface="Calibri" pitchFamily="34" charset="-120"/>
               </a:rPr>
               <a:t>Razorpay Route splits on payment capture</a:t>
             </a:r>
@@ -6976,9 +6976,9 @@
                 <a:solidFill>
                   <a:srgbClr val="6B7280"/>
                 </a:solidFill>
-                <a:latin typeface="DM Sans" pitchFamily="34" charset="0"/>
-                <a:ea typeface="DM Sans" pitchFamily="34" charset="-122"/>
-                <a:cs typeface="DM Sans" pitchFamily="34" charset="-120"/>
+                <a:latin typeface="Calibri" pitchFamily="34" charset="0"/>
+                <a:ea typeface="Calibri" pitchFamily="34" charset="-122"/>
+                <a:cs typeface="Calibri" pitchFamily="34" charset="-120"/>
               </a:rPr>
               <a:t>Platform fee separated automatically. Partner's share transferred directly to their account.</a:t>
             </a:r>
@@ -7040,9 +7040,9 @@
                 <a:solidFill>
                   <a:srgbClr val="FFFFFF"/>
                 </a:solidFill>
-                <a:latin typeface="Syne" pitchFamily="34" charset="0"/>
-                <a:ea typeface="Syne" pitchFamily="34" charset="-122"/>
-                <a:cs typeface="Syne" pitchFamily="34" charset="-120"/>
+                <a:latin typeface="Trebuchet MS" pitchFamily="34" charset="0"/>
+                <a:ea typeface="Trebuchet MS" pitchFamily="34" charset="-122"/>
+                <a:cs typeface="Trebuchet MS" pitchFamily="34" charset="-120"/>
               </a:rPr>
               <a:t>✓</a:t>
             </a:r>
@@ -7079,9 +7079,9 @@
                 <a:solidFill>
                   <a:srgbClr val="0D1117"/>
                 </a:solidFill>
-                <a:latin typeface="DM Sans" pitchFamily="34" charset="0"/>
-                <a:ea typeface="DM Sans" pitchFamily="34" charset="-122"/>
-                <a:cs typeface="DM Sans" pitchFamily="34" charset="-120"/>
+                <a:latin typeface="Calibri" pitchFamily="34" charset="0"/>
+                <a:ea typeface="Calibri" pitchFamily="34" charset="-122"/>
+                <a:cs typeface="Calibri" pitchFamily="34" charset="-120"/>
               </a:rPr>
               <a:t>Settlement in your Razorpay account</a:t>
             </a:r>
@@ -7121,9 +7121,9 @@
                 <a:solidFill>
                   <a:srgbClr val="6B7280"/>
                 </a:solidFill>
-                <a:latin typeface="DM Sans" pitchFamily="34" charset="0"/>
-                <a:ea typeface="DM Sans" pitchFamily="34" charset="-122"/>
-                <a:cs typeface="DM Sans" pitchFamily="34" charset="-120"/>
+                <a:latin typeface="Calibri" pitchFamily="34" charset="0"/>
+                <a:ea typeface="Calibri" pitchFamily="34" charset="-122"/>
+                <a:cs typeface="Calibri" pitchFamily="34" charset="-120"/>
               </a:rPr>
               <a:t>No intermediaries. Direct to the partner's registered bank account.</a:t>
             </a:r>
@@ -7187,9 +7187,9 @@
                 <a:solidFill>
                   <a:srgbClr val="6B7280"/>
                 </a:solidFill>
-                <a:latin typeface="DM Sans" pitchFamily="34" charset="0"/>
-                <a:ea typeface="DM Sans" pitchFamily="34" charset="-122"/>
-                <a:cs typeface="DM Sans" pitchFamily="34" charset="-120"/>
+                <a:latin typeface="Calibri" pitchFamily="34" charset="0"/>
+                <a:ea typeface="Calibri" pitchFamily="34" charset="-122"/>
+                <a:cs typeface="Calibri" pitchFamily="34" charset="-120"/>
               </a:rPr>
               <a:t>EXAMPLE: ₹100 PRINT JOB</a:t>
             </a:r>
@@ -7253,9 +7253,9 @@
                 <a:solidFill>
                   <a:srgbClr val="0D1117"/>
                 </a:solidFill>
-                <a:latin typeface="DM Sans" pitchFamily="34" charset="0"/>
-                <a:ea typeface="DM Sans" pitchFamily="34" charset="-122"/>
-                <a:cs typeface="DM Sans" pitchFamily="34" charset="-120"/>
+                <a:latin typeface="Calibri" pitchFamily="34" charset="0"/>
+                <a:ea typeface="Calibri" pitchFamily="34" charset="-122"/>
+                <a:cs typeface="Calibri" pitchFamily="34" charset="-120"/>
               </a:rPr>
               <a:t>Customer pays</a:t>
             </a:r>
@@ -7292,9 +7292,9 @@
                 <a:solidFill>
                   <a:srgbClr val="0D1117"/>
                 </a:solidFill>
-                <a:latin typeface="Syne" pitchFamily="34" charset="0"/>
-                <a:ea typeface="Syne" pitchFamily="34" charset="-122"/>
-                <a:cs typeface="Syne" pitchFamily="34" charset="-120"/>
+                <a:latin typeface="Trebuchet MS" pitchFamily="34" charset="0"/>
+                <a:ea typeface="Trebuchet MS" pitchFamily="34" charset="-122"/>
+                <a:cs typeface="Trebuchet MS" pitchFamily="34" charset="-120"/>
               </a:rPr>
               <a:t>₹100</a:t>
             </a:r>
@@ -7358,9 +7358,9 @@
                 <a:solidFill>
                   <a:srgbClr val="FFFFFF"/>
                 </a:solidFill>
-                <a:latin typeface="DM Sans" pitchFamily="34" charset="0"/>
-                <a:ea typeface="DM Sans" pitchFamily="34" charset="-122"/>
-                <a:cs typeface="DM Sans" pitchFamily="34" charset="-120"/>
+                <a:latin typeface="Calibri" pitchFamily="34" charset="0"/>
+                <a:ea typeface="Calibri" pitchFamily="34" charset="-122"/>
+                <a:cs typeface="Calibri" pitchFamily="34" charset="-120"/>
               </a:rPr>
               <a:t>Printosky platform fee</a:t>
             </a:r>
@@ -7397,9 +7397,9 @@
                 <a:solidFill>
                   <a:srgbClr val="FFFFFF"/>
                 </a:solidFill>
-                <a:latin typeface="Syne" pitchFamily="34" charset="0"/>
-                <a:ea typeface="Syne" pitchFamily="34" charset="-122"/>
-                <a:cs typeface="Syne" pitchFamily="34" charset="-120"/>
+                <a:latin typeface="Trebuchet MS" pitchFamily="34" charset="0"/>
+                <a:ea typeface="Trebuchet MS" pitchFamily="34" charset="-122"/>
+                <a:cs typeface="Trebuchet MS" pitchFamily="34" charset="-120"/>
               </a:rPr>
               <a:t>₹10</a:t>
             </a:r>
@@ -7463,9 +7463,9 @@
                 <a:solidFill>
                   <a:srgbClr val="FFFFFF"/>
                 </a:solidFill>
-                <a:latin typeface="DM Sans" pitchFamily="34" charset="0"/>
-                <a:ea typeface="DM Sans" pitchFamily="34" charset="-122"/>
-                <a:cs typeface="DM Sans" pitchFamily="34" charset="-120"/>
+                <a:latin typeface="Calibri" pitchFamily="34" charset="0"/>
+                <a:ea typeface="Calibri" pitchFamily="34" charset="-122"/>
+                <a:cs typeface="Calibri" pitchFamily="34" charset="-120"/>
               </a:rPr>
               <a:t>Partner store receives</a:t>
             </a:r>
@@ -7502,9 +7502,9 @@
                 <a:solidFill>
                   <a:srgbClr val="FFFFFF"/>
                 </a:solidFill>
-                <a:latin typeface="Syne" pitchFamily="34" charset="0"/>
-                <a:ea typeface="Syne" pitchFamily="34" charset="-122"/>
-                <a:cs typeface="Syne" pitchFamily="34" charset="-120"/>
+                <a:latin typeface="Trebuchet MS" pitchFamily="34" charset="0"/>
+                <a:ea typeface="Trebuchet MS" pitchFamily="34" charset="-122"/>
+                <a:cs typeface="Trebuchet MS" pitchFamily="34" charset="-120"/>
               </a:rPr>
               <a:t>₹90</a:t>
             </a:r>
@@ -7541,9 +7541,9 @@
                 <a:solidFill>
                   <a:srgbClr val="6B7280"/>
                 </a:solidFill>
-                <a:latin typeface="DM Sans" pitchFamily="34" charset="0"/>
-                <a:ea typeface="DM Sans" pitchFamily="34" charset="-122"/>
-                <a:cs typeface="DM Sans" pitchFamily="34" charset="-120"/>
+                <a:latin typeface="Calibri" pitchFamily="34" charset="0"/>
+                <a:ea typeface="Calibri" pitchFamily="34" charset="-122"/>
+                <a:cs typeface="Calibri" pitchFamily="34" charset="-120"/>
               </a:rPr>
               <a:t>Take-rate is configurable per partner.</a:t>
             </a:r>
@@ -7612,9 +7612,9 @@
                 <a:solidFill>
                   <a:srgbClr val="E8500A"/>
                 </a:solidFill>
-                <a:latin typeface="DM Sans" pitchFamily="34" charset="0"/>
-                <a:ea typeface="DM Sans" pitchFamily="34" charset="-122"/>
-                <a:cs typeface="DM Sans" pitchFamily="34" charset="-120"/>
+                <a:latin typeface="Calibri" pitchFamily="34" charset="0"/>
+                <a:ea typeface="Calibri" pitchFamily="34" charset="-122"/>
+                <a:cs typeface="Calibri" pitchFamily="34" charset="-120"/>
               </a:rPr>
               <a:t>CUSTOMER EXPERIENCE</a:t>
             </a:r>
@@ -7654,9 +7654,9 @@
                 <a:solidFill>
                   <a:srgbClr val="0D1117"/>
                 </a:solidFill>
-                <a:latin typeface="Syne" pitchFamily="34" charset="0"/>
-                <a:ea typeface="Syne" pitchFamily="34" charset="-122"/>
-                <a:cs typeface="Syne" pitchFamily="34" charset="-120"/>
+                <a:latin typeface="Trebuchet MS" pitchFamily="34" charset="0"/>
+                <a:ea typeface="Trebuchet MS" pitchFamily="34" charset="-122"/>
+                <a:cs typeface="Trebuchet MS" pitchFamily="34" charset="-120"/>
               </a:rPr>
               <a:t>Frictionless pickup. Zero confusion.</a:t>
             </a:r>
@@ -7696,9 +7696,9 @@
                 <a:solidFill>
                   <a:srgbClr val="6B7280"/>
                 </a:solidFill>
-                <a:latin typeface="DM Sans" pitchFamily="34" charset="0"/>
-                <a:ea typeface="DM Sans" pitchFamily="34" charset="-122"/>
-                <a:cs typeface="DM Sans" pitchFamily="34" charset="-120"/>
+                <a:latin typeface="Calibri" pitchFamily="34" charset="0"/>
+                <a:ea typeface="Calibri" pitchFamily="34" charset="-122"/>
+                <a:cs typeface="Calibri" pitchFamily="34" charset="-120"/>
               </a:rPr>
               <a:t>Every paid job gets a cryptographically random 4-character code. Customer shows it at the counter — no name lookup, no receipt, no phone call.</a:t>
             </a:r>
@@ -7762,9 +7762,9 @@
                 <a:solidFill>
                   <a:srgbClr val="FFFFFF"/>
                 </a:solidFill>
-                <a:latin typeface="Syne" pitchFamily="34" charset="0"/>
-                <a:ea typeface="Syne" pitchFamily="34" charset="-122"/>
-                <a:cs typeface="Syne" pitchFamily="34" charset="-120"/>
+                <a:latin typeface="Trebuchet MS" pitchFamily="34" charset="0"/>
+                <a:ea typeface="Trebuchet MS" pitchFamily="34" charset="-122"/>
+                <a:cs typeface="Trebuchet MS" pitchFamily="34" charset="-120"/>
               </a:rPr>
               <a:t>P‑4K8X</a:t>
             </a:r>
@@ -7826,9 +7826,9 @@
                 <a:solidFill>
                   <a:srgbClr val="FFFFFF"/>
                 </a:solidFill>
-                <a:latin typeface="Syne" pitchFamily="34" charset="0"/>
-                <a:ea typeface="Syne" pitchFamily="34" charset="-122"/>
-                <a:cs typeface="Syne" pitchFamily="34" charset="-120"/>
+                <a:latin typeface="Trebuchet MS" pitchFamily="34" charset="0"/>
+                <a:ea typeface="Trebuchet MS" pitchFamily="34" charset="-122"/>
+                <a:cs typeface="Trebuchet MS" pitchFamily="34" charset="-120"/>
               </a:rPr>
               <a:t>📲</a:t>
             </a:r>
@@ -7865,9 +7865,9 @@
                 <a:solidFill>
                   <a:srgbClr val="0D1117"/>
                 </a:solidFill>
-                <a:latin typeface="DM Sans" pitchFamily="34" charset="0"/>
-                <a:ea typeface="DM Sans" pitchFamily="34" charset="-122"/>
-                <a:cs typeface="DM Sans" pitchFamily="34" charset="-120"/>
+                <a:latin typeface="Calibri" pitchFamily="34" charset="0"/>
+                <a:ea typeface="Calibri" pitchFamily="34" charset="-122"/>
+                <a:cs typeface="Calibri" pitchFamily="34" charset="-120"/>
               </a:rPr>
               <a:t>Sent via WhatsApp when job is ready</a:t>
             </a:r>
@@ -7907,9 +7907,9 @@
                 <a:solidFill>
                   <a:srgbClr val="6B7280"/>
                 </a:solidFill>
-                <a:latin typeface="DM Sans" pitchFamily="34" charset="0"/>
-                <a:ea typeface="DM Sans" pitchFamily="34" charset="-122"/>
-                <a:cs typeface="DM Sans" pitchFamily="34" charset="-120"/>
+                <a:latin typeface="Calibri" pitchFamily="34" charset="0"/>
+                <a:ea typeface="Calibri" pitchFamily="34" charset="-122"/>
+                <a:cs typeface="Calibri" pitchFamily="34" charset="-120"/>
               </a:rPr>
               <a:t>Store marks ready → WhatsApp notification fires instantly.</a:t>
             </a:r>
@@ -7971,9 +7971,9 @@
                 <a:solidFill>
                   <a:srgbClr val="FFFFFF"/>
                 </a:solidFill>
-                <a:latin typeface="Syne" pitchFamily="34" charset="0"/>
-                <a:ea typeface="Syne" pitchFamily="34" charset="-122"/>
-                <a:cs typeface="Syne" pitchFamily="34" charset="-120"/>
+                <a:latin typeface="Trebuchet MS" pitchFamily="34" charset="0"/>
+                <a:ea typeface="Trebuchet MS" pitchFamily="34" charset="-122"/>
+                <a:cs typeface="Trebuchet MS" pitchFamily="34" charset="-120"/>
               </a:rPr>
               <a:t>🔍</a:t>
             </a:r>
@@ -8010,9 +8010,9 @@
                 <a:solidFill>
                   <a:srgbClr val="0D1117"/>
                 </a:solidFill>
-                <a:latin typeface="DM Sans" pitchFamily="34" charset="0"/>
-                <a:ea typeface="DM Sans" pitchFamily="34" charset="-122"/>
-                <a:cs typeface="DM Sans" pitchFamily="34" charset="-120"/>
+                <a:latin typeface="Calibri" pitchFamily="34" charset="0"/>
+                <a:ea typeface="Calibri" pitchFamily="34" charset="-122"/>
+                <a:cs typeface="Calibri" pitchFamily="34" charset="-120"/>
               </a:rPr>
               <a:t>Live tracking at printosky.com/track</a:t>
             </a:r>
@@ -8052,9 +8052,9 @@
                 <a:solidFill>
                   <a:srgbClr val="6B7280"/>
                 </a:solidFill>
-                <a:latin typeface="DM Sans" pitchFamily="34" charset="0"/>
-                <a:ea typeface="DM Sans" pitchFamily="34" charset="-122"/>
-                <a:cs typeface="DM Sans" pitchFamily="34" charset="-120"/>
+                <a:latin typeface="Calibri" pitchFamily="34" charset="0"/>
+                <a:ea typeface="Calibri" pitchFamily="34" charset="-122"/>
+                <a:cs typeface="Calibri" pitchFamily="34" charset="-120"/>
               </a:rPr>
               <a:t>No login. 5 stages: Received → Paid → Printing → Ready → Delivered.</a:t>
             </a:r>
@@ -8118,9 +8118,9 @@
                 <a:solidFill>
                   <a:srgbClr val="6B7280"/>
                 </a:solidFill>
-                <a:latin typeface="DM Sans" pitchFamily="34" charset="0"/>
-                <a:ea typeface="DM Sans" pitchFamily="34" charset="-122"/>
-                <a:cs typeface="DM Sans" pitchFamily="34" charset="-120"/>
+                <a:latin typeface="Calibri" pitchFamily="34" charset="0"/>
+                <a:ea typeface="Calibri" pitchFamily="34" charset="-122"/>
+                <a:cs typeface="Calibri" pitchFamily="34" charset="-120"/>
               </a:rPr>
               <a:t>ORDER #P‑4K8X · LIVE STATUS</a:t>
             </a:r>
@@ -8182,9 +8182,9 @@
                 <a:solidFill>
                   <a:srgbClr val="6B7280"/>
                 </a:solidFill>
-                <a:latin typeface="DM Sans" pitchFamily="34" charset="0"/>
-                <a:ea typeface="DM Sans" pitchFamily="34" charset="-122"/>
-                <a:cs typeface="DM Sans" pitchFamily="34" charset="-120"/>
+                <a:latin typeface="Calibri" pitchFamily="34" charset="0"/>
+                <a:ea typeface="Calibri" pitchFamily="34" charset="-122"/>
+                <a:cs typeface="Calibri" pitchFamily="34" charset="-120"/>
               </a:rPr>
               <a:t>Received</a:t>
             </a:r>
@@ -8221,9 +8221,9 @@
                 <a:solidFill>
                   <a:srgbClr val="6B7280"/>
                 </a:solidFill>
-                <a:latin typeface="DM Sans" pitchFamily="34" charset="0"/>
-                <a:ea typeface="DM Sans" pitchFamily="34" charset="-122"/>
-                <a:cs typeface="DM Sans" pitchFamily="34" charset="-120"/>
+                <a:latin typeface="Calibri" pitchFamily="34" charset="0"/>
+                <a:ea typeface="Calibri" pitchFamily="34" charset="-122"/>
+                <a:cs typeface="Calibri" pitchFamily="34" charset="-120"/>
               </a:rPr>
               <a:t>✓</a:t>
             </a:r>
@@ -8285,9 +8285,9 @@
                 <a:solidFill>
                   <a:srgbClr val="6B7280"/>
                 </a:solidFill>
-                <a:latin typeface="DM Sans" pitchFamily="34" charset="0"/>
-                <a:ea typeface="DM Sans" pitchFamily="34" charset="-122"/>
-                <a:cs typeface="DM Sans" pitchFamily="34" charset="-120"/>
+                <a:latin typeface="Calibri" pitchFamily="34" charset="0"/>
+                <a:ea typeface="Calibri" pitchFamily="34" charset="-122"/>
+                <a:cs typeface="Calibri" pitchFamily="34" charset="-120"/>
               </a:rPr>
               <a:t>Paid</a:t>
             </a:r>
@@ -8324,9 +8324,9 @@
                 <a:solidFill>
                   <a:srgbClr val="6B7280"/>
                 </a:solidFill>
-                <a:latin typeface="DM Sans" pitchFamily="34" charset="0"/>
-                <a:ea typeface="DM Sans" pitchFamily="34" charset="-122"/>
-                <a:cs typeface="DM Sans" pitchFamily="34" charset="-120"/>
+                <a:latin typeface="Calibri" pitchFamily="34" charset="0"/>
+                <a:ea typeface="Calibri" pitchFamily="34" charset="-122"/>
+                <a:cs typeface="Calibri" pitchFamily="34" charset="-120"/>
               </a:rPr>
               <a:t>✓</a:t>
             </a:r>
@@ -8388,9 +8388,9 @@
                 <a:solidFill>
                   <a:srgbClr val="0D1117"/>
                 </a:solidFill>
-                <a:latin typeface="DM Sans" pitchFamily="34" charset="0"/>
-                <a:ea typeface="DM Sans" pitchFamily="34" charset="-122"/>
-                <a:cs typeface="DM Sans" pitchFamily="34" charset="-120"/>
+                <a:latin typeface="Calibri" pitchFamily="34" charset="0"/>
+                <a:ea typeface="Calibri" pitchFamily="34" charset="-122"/>
+                <a:cs typeface="Calibri" pitchFamily="34" charset="-120"/>
               </a:rPr>
               <a:t>Printing</a:t>
             </a:r>
@@ -8427,9 +8427,9 @@
                 <a:solidFill>
                   <a:srgbClr val="E8500A"/>
                 </a:solidFill>
-                <a:latin typeface="DM Sans" pitchFamily="34" charset="0"/>
-                <a:ea typeface="DM Sans" pitchFamily="34" charset="-122"/>
-                <a:cs typeface="DM Sans" pitchFamily="34" charset="-120"/>
+                <a:latin typeface="Calibri" pitchFamily="34" charset="0"/>
+                <a:ea typeface="Calibri" pitchFamily="34" charset="-122"/>
+                <a:cs typeface="Calibri" pitchFamily="34" charset="-120"/>
               </a:rPr>
               <a:t>⟳ In progress</a:t>
             </a:r>
@@ -8491,9 +8491,9 @@
                 <a:solidFill>
                   <a:srgbClr val="CCCCCC"/>
                 </a:solidFill>
-                <a:latin typeface="DM Sans" pitchFamily="34" charset="0"/>
-                <a:ea typeface="DM Sans" pitchFamily="34" charset="-122"/>
-                <a:cs typeface="DM Sans" pitchFamily="34" charset="-120"/>
+                <a:latin typeface="Calibri" pitchFamily="34" charset="0"/>
+                <a:ea typeface="Calibri" pitchFamily="34" charset="-122"/>
+                <a:cs typeface="Calibri" pitchFamily="34" charset="-120"/>
               </a:rPr>
               <a:t>Ready for pickup</a:t>
             </a:r>
@@ -8555,9 +8555,9 @@
                 <a:solidFill>
                   <a:srgbClr val="CCCCCC"/>
                 </a:solidFill>
-                <a:latin typeface="DM Sans" pitchFamily="34" charset="0"/>
-                <a:ea typeface="DM Sans" pitchFamily="34" charset="-122"/>
-                <a:cs typeface="DM Sans" pitchFamily="34" charset="-120"/>
+                <a:latin typeface="Calibri" pitchFamily="34" charset="0"/>
+                <a:ea typeface="Calibri" pitchFamily="34" charset="-122"/>
+                <a:cs typeface="Calibri" pitchFamily="34" charset="-120"/>
               </a:rPr>
               <a:t>Delivered</a:t>
             </a:r>
@@ -8594,9 +8594,9 @@
                 <a:solidFill>
                   <a:srgbClr val="6B7280"/>
                 </a:solidFill>
-                <a:latin typeface="DM Sans" pitchFamily="34" charset="0"/>
-                <a:ea typeface="DM Sans" pitchFamily="34" charset="-122"/>
-                <a:cs typeface="DM Sans" pitchFamily="34" charset="-120"/>
+                <a:latin typeface="Calibri" pitchFamily="34" charset="0"/>
+                <a:ea typeface="Calibri" pitchFamily="34" charset="-122"/>
+                <a:cs typeface="Calibri" pitchFamily="34" charset="-120"/>
               </a:rPr>
               <a:t>printosky.com/track · No login required</a:t>
             </a:r>
@@ -8665,9 +8665,9 @@
                 <a:solidFill>
                   <a:srgbClr val="E8500A"/>
                 </a:solidFill>
-                <a:latin typeface="DM Sans" pitchFamily="34" charset="0"/>
-                <a:ea typeface="DM Sans" pitchFamily="34" charset="-122"/>
-                <a:cs typeface="DM Sans" pitchFamily="34" charset="-120"/>
+                <a:latin typeface="Calibri" pitchFamily="34" charset="0"/>
+                <a:ea typeface="Calibri" pitchFamily="34" charset="-122"/>
+                <a:cs typeface="Calibri" pitchFamily="34" charset="-120"/>
               </a:rPr>
               <a:t>TRACTION</a:t>
             </a:r>
@@ -8707,9 +8707,9 @@
                 <a:solidFill>
                   <a:srgbClr val="FFFFFF"/>
                 </a:solidFill>
-                <a:latin typeface="Syne" pitchFamily="34" charset="0"/>
-                <a:ea typeface="Syne" pitchFamily="34" charset="-122"/>
-                <a:cs typeface="Syne" pitchFamily="34" charset="-120"/>
+                <a:latin typeface="Trebuchet MS" pitchFamily="34" charset="0"/>
+                <a:ea typeface="Trebuchet MS" pitchFamily="34" charset="-122"/>
+                <a:cs typeface="Trebuchet MS" pitchFamily="34" charset="-120"/>
               </a:rPr>
               <a:t>Built on a real, live store.</a:t>
             </a:r>
@@ -8749,9 +8749,9 @@
                 <a:solidFill>
                   <a:srgbClr val="AACCEE"/>
                 </a:solidFill>
-                <a:latin typeface="DM Sans" pitchFamily="34" charset="0"/>
-                <a:ea typeface="DM Sans" pitchFamily="34" charset="-122"/>
-                <a:cs typeface="DM Sans" pitchFamily="34" charset="-120"/>
+                <a:latin typeface="Calibri" pitchFamily="34" charset="0"/>
+                <a:ea typeface="Calibri" pitchFamily="34" charset="-122"/>
+                <a:cs typeface="Calibri" pitchFamily="34" charset="-120"/>
               </a:rPr>
               <a:t>Printosky is not a concept deck. It runs live at Oxygen Students Paradise, Thriprayar, Thrissur — processing real print jobs, real payments, real customers every day.</a:t>
             </a:r>
@@ -8788,9 +8788,9 @@
                 <a:solidFill>
                   <a:srgbClr val="FFFFFF"/>
                 </a:solidFill>
-                <a:latin typeface="Syne" pitchFamily="34" charset="0"/>
-                <a:ea typeface="Syne" pitchFamily="34" charset="-122"/>
-                <a:cs typeface="Syne" pitchFamily="34" charset="-120"/>
+                <a:latin typeface="Trebuchet MS" pitchFamily="34" charset="0"/>
+                <a:ea typeface="Trebuchet MS" pitchFamily="34" charset="-122"/>
+                <a:cs typeface="Trebuchet MS" pitchFamily="34" charset="-120"/>
               </a:rPr>
               <a:t>134+</a:t>
             </a:r>
@@ -8830,9 +8830,9 @@
                 <a:solidFill>
                   <a:srgbClr val="AAAAAA"/>
                 </a:solidFill>
-                <a:latin typeface="DM Sans" pitchFamily="34" charset="0"/>
-                <a:ea typeface="DM Sans" pitchFamily="34" charset="-122"/>
-                <a:cs typeface="DM Sans" pitchFamily="34" charset="-120"/>
+                <a:latin typeface="Calibri" pitchFamily="34" charset="0"/>
+                <a:ea typeface="Calibri" pitchFamily="34" charset="-122"/>
+                <a:cs typeface="Calibri" pitchFamily="34" charset="-120"/>
               </a:rPr>
               <a:t>Jobs processed via the platform</a:t>
             </a:r>
@@ -8869,9 +8869,9 @@
                 <a:solidFill>
                   <a:srgbClr val="FFFFFF"/>
                 </a:solidFill>
-                <a:latin typeface="Syne" pitchFamily="34" charset="0"/>
-                <a:ea typeface="Syne" pitchFamily="34" charset="-122"/>
-                <a:cs typeface="Syne" pitchFamily="34" charset="-120"/>
+                <a:latin typeface="Trebuchet MS" pitchFamily="34" charset="0"/>
+                <a:ea typeface="Trebuchet MS" pitchFamily="34" charset="-122"/>
+                <a:cs typeface="Trebuchet MS" pitchFamily="34" charset="-120"/>
               </a:rPr>
               <a:t>2+</a:t>
             </a:r>
@@ -8911,9 +8911,9 @@
                 <a:solidFill>
                   <a:srgbClr val="AAAAAA"/>
                 </a:solidFill>
-                <a:latin typeface="DM Sans" pitchFamily="34" charset="0"/>
-                <a:ea typeface="DM Sans" pitchFamily="34" charset="-122"/>
-                <a:cs typeface="DM Sans" pitchFamily="34" charset="-120"/>
+                <a:latin typeface="Calibri" pitchFamily="34" charset="0"/>
+                <a:ea typeface="Calibri" pitchFamily="34" charset="-122"/>
+                <a:cs typeface="Calibri" pitchFamily="34" charset="-120"/>
               </a:rPr>
               <a:t>Production printers (Konica + Epson)</a:t>
             </a:r>
@@ -8950,9 +8950,9 @@
                 <a:solidFill>
                   <a:srgbClr val="FFFFFF"/>
                 </a:solidFill>
-                <a:latin typeface="Syne" pitchFamily="34" charset="0"/>
-                <a:ea typeface="Syne" pitchFamily="34" charset="-122"/>
-                <a:cs typeface="Syne" pitchFamily="34" charset="-120"/>
+                <a:latin typeface="Trebuchet MS" pitchFamily="34" charset="0"/>
+                <a:ea typeface="Trebuchet MS" pitchFamily="34" charset="-122"/>
+                <a:cs typeface="Trebuchet MS" pitchFamily="34" charset="-120"/>
               </a:rPr>
               <a:t>₹0</a:t>
             </a:r>
@@ -8992,9 +8992,9 @@
                 <a:solidFill>
                   <a:srgbClr val="AAAAAA"/>
                 </a:solidFill>
-                <a:latin typeface="DM Sans" pitchFamily="34" charset="0"/>
-                <a:ea typeface="DM Sans" pitchFamily="34" charset="-122"/>
-                <a:cs typeface="DM Sans" pitchFamily="34" charset="-120"/>
+                <a:latin typeface="Calibri" pitchFamily="34" charset="0"/>
+                <a:ea typeface="Calibri" pitchFamily="34" charset="-122"/>
+                <a:cs typeface="Calibri" pitchFamily="34" charset="-120"/>
               </a:rPr>
               <a:t>Cash — 100% digital payments via Razorpay</a:t>
             </a:r>
@@ -9061,9 +9061,9 @@
                 <a:solidFill>
                   <a:srgbClr val="AAAAAA"/>
                 </a:solidFill>
-                <a:latin typeface="DM Sans" pitchFamily="34" charset="0"/>
-                <a:ea typeface="DM Sans" pitchFamily="34" charset="-122"/>
-                <a:cs typeface="DM Sans" pitchFamily="34" charset="-120"/>
+                <a:latin typeface="Calibri" pitchFamily="34" charset="0"/>
+                <a:ea typeface="Calibri" pitchFamily="34" charset="-122"/>
+                <a:cs typeface="Calibri" pitchFamily="34" charset="-120"/>
               </a:rPr>
               <a:t>Full stack since 2025: Store PC → Watcher → Konica / Epson  ·  WhatsApp Cloud API (Meta)  ·  Razorpay  ·  Supabase  ·  Vercel API  ·  Netlify</a:t>
             </a:r>

</xml_diff>